<commit_message>
BACKUP: Pre-redesign baseline — MERN audit complete, split-brain tokens, page duplication documented
</commit_message>
<xml_diff>
--- a/Combined Review - NewsGuard AI.pptx
+++ b/Combined Review - NewsGuard AI.pptx
@@ -5,26 +5,27 @@
     <p:sldMasterId id="2147483648" r:id="rId1"/>
   </p:sldMasterIdLst>
   <p:notesMasterIdLst>
-    <p:notesMasterId r:id="rId19"/>
+    <p:notesMasterId r:id="rId20"/>
   </p:notesMasterIdLst>
   <p:sldIdLst>
-    <p:sldId id="257" r:id="rId2"/>
-    <p:sldId id="258" r:id="rId3"/>
-    <p:sldId id="259" r:id="rId4"/>
-    <p:sldId id="260" r:id="rId5"/>
-    <p:sldId id="261" r:id="rId6"/>
-    <p:sldId id="262" r:id="rId7"/>
-    <p:sldId id="263" r:id="rId8"/>
-    <p:sldId id="264" r:id="rId9"/>
-    <p:sldId id="265" r:id="rId10"/>
-    <p:sldId id="266" r:id="rId11"/>
-    <p:sldId id="267" r:id="rId12"/>
-    <p:sldId id="268" r:id="rId13"/>
-    <p:sldId id="269" r:id="rId14"/>
-    <p:sldId id="270" r:id="rId15"/>
-    <p:sldId id="272" r:id="rId16"/>
-    <p:sldId id="273" r:id="rId17"/>
-    <p:sldId id="275" r:id="rId18"/>
+    <p:sldId id="256" r:id="rId2"/>
+    <p:sldId id="257" r:id="rId3"/>
+    <p:sldId id="258" r:id="rId4"/>
+    <p:sldId id="259" r:id="rId5"/>
+    <p:sldId id="260" r:id="rId6"/>
+    <p:sldId id="261" r:id="rId7"/>
+    <p:sldId id="262" r:id="rId8"/>
+    <p:sldId id="263" r:id="rId9"/>
+    <p:sldId id="264" r:id="rId10"/>
+    <p:sldId id="265" r:id="rId11"/>
+    <p:sldId id="266" r:id="rId12"/>
+    <p:sldId id="267" r:id="rId13"/>
+    <p:sldId id="268" r:id="rId14"/>
+    <p:sldId id="269" r:id="rId15"/>
+    <p:sldId id="270" r:id="rId16"/>
+    <p:sldId id="272" r:id="rId17"/>
+    <p:sldId id="273" r:id="rId18"/>
+    <p:sldId id="275" r:id="rId19"/>
   </p:sldIdLst>
   <p:sldSz cx="12192000" cy="6858000"/>
   <p:notesSz cx="6858000" cy="12192000"/>
@@ -318,7 +319,7 @@
           <a:p>
             <a:fld id="{F7021451-1387-4CA6-816F-3879F97B5CBC}" type="slidenum">
               <a:rPr lang="en-US"/>
-              <a:t>1</a:t>
+              <a:t>2</a:t>
             </a:fld>
             <a:endParaRPr lang="en-US"/>
           </a:p>
@@ -402,7 +403,7 @@
           <a:p>
             <a:fld id="{F7021451-1387-4CA6-816F-3879F97B5CBC}" type="slidenum">
               <a:rPr lang="en-US"/>
-              <a:t>10</a:t>
+              <a:t>11</a:t>
             </a:fld>
             <a:endParaRPr lang="en-US"/>
           </a:p>
@@ -486,7 +487,7 @@
           <a:p>
             <a:fld id="{F7021451-1387-4CA6-816F-3879F97B5CBC}" type="slidenum">
               <a:rPr lang="en-US"/>
-              <a:t>11</a:t>
+              <a:t>12</a:t>
             </a:fld>
             <a:endParaRPr lang="en-US"/>
           </a:p>
@@ -570,7 +571,7 @@
           <a:p>
             <a:fld id="{F7021451-1387-4CA6-816F-3879F97B5CBC}" type="slidenum">
               <a:rPr lang="en-US"/>
-              <a:t>12</a:t>
+              <a:t>13</a:t>
             </a:fld>
             <a:endParaRPr lang="en-US"/>
           </a:p>
@@ -654,7 +655,7 @@
           <a:p>
             <a:fld id="{F7021451-1387-4CA6-816F-3879F97B5CBC}" type="slidenum">
               <a:rPr lang="en-US"/>
-              <a:t>13</a:t>
+              <a:t>14</a:t>
             </a:fld>
             <a:endParaRPr lang="en-US"/>
           </a:p>
@@ -738,7 +739,7 @@
           <a:p>
             <a:fld id="{F7021451-1387-4CA6-816F-3879F97B5CBC}" type="slidenum">
               <a:rPr lang="en-US"/>
-              <a:t>14</a:t>
+              <a:t>15</a:t>
             </a:fld>
             <a:endParaRPr lang="en-US"/>
           </a:p>
@@ -822,7 +823,7 @@
           <a:p>
             <a:fld id="{F7021451-1387-4CA6-816F-3879F97B5CBC}" type="slidenum">
               <a:rPr lang="en-US"/>
-              <a:t>15</a:t>
+              <a:t>16</a:t>
             </a:fld>
             <a:endParaRPr lang="en-US"/>
           </a:p>
@@ -906,7 +907,7 @@
           <a:p>
             <a:fld id="{F7021451-1387-4CA6-816F-3879F97B5CBC}" type="slidenum">
               <a:rPr lang="en-US"/>
-              <a:t>16</a:t>
+              <a:t>17</a:t>
             </a:fld>
             <a:endParaRPr lang="en-US"/>
           </a:p>
@@ -990,7 +991,7 @@
           <a:p>
             <a:fld id="{F7021451-1387-4CA6-816F-3879F97B5CBC}" type="slidenum">
               <a:rPr lang="en-US"/>
-              <a:t>17</a:t>
+              <a:t>18</a:t>
             </a:fld>
             <a:endParaRPr lang="en-US"/>
           </a:p>
@@ -1074,7 +1075,7 @@
           <a:p>
             <a:fld id="{F7021451-1387-4CA6-816F-3879F97B5CBC}" type="slidenum">
               <a:rPr lang="en-US"/>
-              <a:t>2</a:t>
+              <a:t>3</a:t>
             </a:fld>
             <a:endParaRPr lang="en-US"/>
           </a:p>
@@ -1158,7 +1159,7 @@
           <a:p>
             <a:fld id="{F7021451-1387-4CA6-816F-3879F97B5CBC}" type="slidenum">
               <a:rPr lang="en-US"/>
-              <a:t>3</a:t>
+              <a:t>4</a:t>
             </a:fld>
             <a:endParaRPr lang="en-US"/>
           </a:p>
@@ -1242,7 +1243,7 @@
           <a:p>
             <a:fld id="{F7021451-1387-4CA6-816F-3879F97B5CBC}" type="slidenum">
               <a:rPr lang="en-US"/>
-              <a:t>4</a:t>
+              <a:t>5</a:t>
             </a:fld>
             <a:endParaRPr lang="en-US"/>
           </a:p>
@@ -1326,7 +1327,7 @@
           <a:p>
             <a:fld id="{F7021451-1387-4CA6-816F-3879F97B5CBC}" type="slidenum">
               <a:rPr lang="en-US"/>
-              <a:t>5</a:t>
+              <a:t>6</a:t>
             </a:fld>
             <a:endParaRPr lang="en-US"/>
           </a:p>
@@ -1410,7 +1411,7 @@
           <a:p>
             <a:fld id="{F7021451-1387-4CA6-816F-3879F97B5CBC}" type="slidenum">
               <a:rPr lang="en-US"/>
-              <a:t>6</a:t>
+              <a:t>7</a:t>
             </a:fld>
             <a:endParaRPr lang="en-US"/>
           </a:p>
@@ -1494,7 +1495,7 @@
           <a:p>
             <a:fld id="{F7021451-1387-4CA6-816F-3879F97B5CBC}" type="slidenum">
               <a:rPr lang="en-US"/>
-              <a:t>7</a:t>
+              <a:t>8</a:t>
             </a:fld>
             <a:endParaRPr lang="en-US"/>
           </a:p>
@@ -1578,7 +1579,7 @@
           <a:p>
             <a:fld id="{F7021451-1387-4CA6-816F-3879F97B5CBC}" type="slidenum">
               <a:rPr lang="en-US"/>
-              <a:t>8</a:t>
+              <a:t>9</a:t>
             </a:fld>
             <a:endParaRPr lang="en-US"/>
           </a:p>
@@ -1662,7 +1663,7 @@
           <a:p>
             <a:fld id="{F7021451-1387-4CA6-816F-3879F97B5CBC}" type="slidenum">
               <a:rPr lang="en-US"/>
-              <a:t>9</a:t>
+              <a:t>10</a:t>
             </a:fld>
             <a:endParaRPr lang="en-US"/>
           </a:p>
@@ -1711,6 +1712,103 @@
 </p:sldLayout>
 </file>
 
+<file path=ppt/slideLayouts/slideLayout2.xml><?xml version="1.0" encoding="utf-8"?>
+<p:sldLayout xmlns:a="http://schemas.openxmlformats.org/drawingml/2006/main" xmlns:r="http://schemas.openxmlformats.org/officeDocument/2006/relationships" xmlns:p="http://schemas.openxmlformats.org/presentationml/2006/main" type="blank">
+  <p:cSld name="Blank">
+    <p:spTree>
+      <p:nvGrpSpPr>
+        <p:cNvPr id="1" name=""/>
+        <p:cNvGrpSpPr/>
+        <p:nvPr/>
+      </p:nvGrpSpPr>
+      <p:grpSpPr>
+        <a:xfrm>
+          <a:off x="0" y="0"/>
+          <a:ext cx="0" cy="0"/>
+          <a:chOff x="0" y="0"/>
+          <a:chExt cx="0" cy="0"/>
+        </a:xfrm>
+      </p:grpSpPr>
+      <p:sp>
+        <p:nvSpPr>
+          <p:cNvPr id="2" name="Date Placeholder 1"/>
+          <p:cNvSpPr>
+            <a:spLocks noGrp="1"/>
+          </p:cNvSpPr>
+          <p:nvPr>
+            <p:ph type="dt" sz="half" idx="10"/>
+          </p:nvPr>
+        </p:nvSpPr>
+        <p:spPr/>
+        <p:txBody>
+          <a:bodyPr/>
+          <a:lstStyle/>
+          <a:p>
+            <a:fld id="{1D8BD707-D9CF-40AE-B4C6-C98DA3205C09}" type="datetimeFigureOut">
+              <a:rPr lang="en-US" smtClean="0"/>
+              <a:pPr/>
+              <a:t>9/30/2026</a:t>
+            </a:fld>
+            <a:endParaRPr lang="en-US"/>
+          </a:p>
+        </p:txBody>
+      </p:sp>
+      <p:sp>
+        <p:nvSpPr>
+          <p:cNvPr id="3" name="Footer Placeholder 2"/>
+          <p:cNvSpPr>
+            <a:spLocks noGrp="1"/>
+          </p:cNvSpPr>
+          <p:nvPr>
+            <p:ph type="ftr" sz="quarter" idx="11"/>
+          </p:nvPr>
+        </p:nvSpPr>
+        <p:spPr/>
+        <p:txBody>
+          <a:bodyPr/>
+          <a:lstStyle/>
+          <a:p>
+            <a:endParaRPr lang="en-US"/>
+          </a:p>
+        </p:txBody>
+      </p:sp>
+      <p:sp>
+        <p:nvSpPr>
+          <p:cNvPr id="4" name="Slide Number Placeholder 3"/>
+          <p:cNvSpPr>
+            <a:spLocks noGrp="1"/>
+          </p:cNvSpPr>
+          <p:nvPr>
+            <p:ph type="sldNum" sz="quarter" idx="12"/>
+          </p:nvPr>
+        </p:nvSpPr>
+        <p:spPr/>
+        <p:txBody>
+          <a:bodyPr/>
+          <a:lstStyle/>
+          <a:p>
+            <a:fld id="{B6F15528-21DE-4FAA-801E-634DDDAF4B2B}" type="slidenum">
+              <a:rPr lang="en-US" smtClean="0"/>
+              <a:pPr/>
+              <a:t>‹#›</a:t>
+            </a:fld>
+            <a:endParaRPr lang="en-US"/>
+          </a:p>
+        </p:txBody>
+      </p:sp>
+    </p:spTree>
+    <p:extLst>
+      <p:ext uri="{BB962C8B-B14F-4D97-AF65-F5344CB8AC3E}">
+        <p14:creationId xmlns:p14="http://schemas.microsoft.com/office/powerpoint/2010/main" val="1064706409"/>
+      </p:ext>
+    </p:extLst>
+  </p:cSld>
+  <p:clrMapOvr>
+    <a:masterClrMapping/>
+  </p:clrMapOvr>
+</p:sldLayout>
+</file>
+
 <file path=ppt/slideMasters/slideMaster1.xml><?xml version="1.0" encoding="utf-8"?>
 <p:sldMaster xmlns:a="http://schemas.openxmlformats.org/drawingml/2006/main" xmlns:r="http://schemas.openxmlformats.org/officeDocument/2006/relationships" xmlns:p="http://schemas.openxmlformats.org/presentationml/2006/main">
   <p:cSld>
@@ -1738,6 +1836,7 @@
   <p:clrMap bg1="lt1" tx1="dk1" bg2="lt2" tx2="dk2" accent1="accent1" accent2="accent2" accent3="accent3" accent4="accent4" accent5="accent5" accent6="accent6" hlink="hlink" folHlink="folHlink"/>
   <p:sldLayoutIdLst>
     <p:sldLayoutId id="2147483649" r:id="rId1"/>
+    <p:sldLayoutId id="2147483650" r:id="rId2"/>
   </p:sldLayoutIdLst>
   <p:hf sldNum="0" hdr="0" ftr="0" dt="0"/>
   <p:txStyles>
@@ -1995,7 +2094,675 @@
 
 <file path=ppt/slides/slide1.xml><?xml version="1.0" encoding="utf-8"?>
 <p:sld xmlns:a="http://schemas.openxmlformats.org/drawingml/2006/main" xmlns:r="http://schemas.openxmlformats.org/officeDocument/2006/relationships" xmlns:p="http://schemas.openxmlformats.org/presentationml/2006/main">
-  <p:cSld name="Slide 2">
+  <p:cSld>
+    <p:spTree>
+      <p:nvGrpSpPr>
+        <p:cNvPr id="1" name=""/>
+        <p:cNvGrpSpPr/>
+        <p:nvPr/>
+      </p:nvGrpSpPr>
+      <p:grpSpPr>
+        <a:xfrm>
+          <a:off x="0" y="0"/>
+          <a:ext cx="0" cy="0"/>
+          <a:chOff x="0" y="0"/>
+          <a:chExt cx="0" cy="0"/>
+        </a:xfrm>
+      </p:grpSpPr>
+      <p:sp>
+        <p:nvSpPr>
+          <p:cNvPr id="2" name="Freeform 2"/>
+          <p:cNvSpPr/>
+          <p:nvPr/>
+        </p:nvSpPr>
+        <p:spPr>
+          <a:xfrm>
+            <a:off x="0" y="0"/>
+            <a:ext cx="12192000" cy="6858000"/>
+          </a:xfrm>
+          <a:custGeom>
+            <a:avLst/>
+            <a:gdLst/>
+            <a:ahLst/>
+            <a:cxnLst/>
+            <a:rect l="l" t="t" r="r" b="b"/>
+            <a:pathLst>
+              <a:path w="18288000" h="10287000">
+                <a:moveTo>
+                  <a:pt x="0" y="0"/>
+                </a:moveTo>
+                <a:lnTo>
+                  <a:pt x="18288000" y="0"/>
+                </a:lnTo>
+                <a:lnTo>
+                  <a:pt x="18288000" y="10287000"/>
+                </a:lnTo>
+                <a:lnTo>
+                  <a:pt x="0" y="10287000"/>
+                </a:lnTo>
+                <a:lnTo>
+                  <a:pt x="0" y="0"/>
+                </a:lnTo>
+                <a:close/>
+              </a:path>
+            </a:pathLst>
+          </a:custGeom>
+          <a:blipFill>
+            <a:blip>
+              <a:extLst>
+                <a:ext uri="{96DAC541-7B7A-43D3-8B79-37D633B846F1}">
+                  <asvg:svgBlip xmlns:asvg="http://schemas.microsoft.com/office/drawing/2016/SVG/main" r:embed="rId2"/>
+                </a:ext>
+              </a:extLst>
+            </a:blip>
+            <a:stretch>
+              <a:fillRect/>
+            </a:stretch>
+          </a:blipFill>
+        </p:spPr>
+      </p:sp>
+      <p:sp>
+        <p:nvSpPr>
+          <p:cNvPr id="3" name="Freeform 3"/>
+          <p:cNvSpPr/>
+          <p:nvPr/>
+        </p:nvSpPr>
+        <p:spPr>
+          <a:xfrm>
+            <a:off x="1" y="228600"/>
+            <a:ext cx="2851518" cy="6638627"/>
+          </a:xfrm>
+          <a:custGeom>
+            <a:avLst/>
+            <a:gdLst/>
+            <a:ahLst/>
+            <a:cxnLst/>
+            <a:rect l="l" t="t" r="r" b="b"/>
+            <a:pathLst>
+              <a:path w="4277277" h="9957940">
+                <a:moveTo>
+                  <a:pt x="0" y="0"/>
+                </a:moveTo>
+                <a:lnTo>
+                  <a:pt x="4277278" y="0"/>
+                </a:lnTo>
+                <a:lnTo>
+                  <a:pt x="4277278" y="9957940"/>
+                </a:lnTo>
+                <a:lnTo>
+                  <a:pt x="0" y="9957940"/>
+                </a:lnTo>
+                <a:lnTo>
+                  <a:pt x="0" y="0"/>
+                </a:lnTo>
+                <a:close/>
+              </a:path>
+            </a:pathLst>
+          </a:custGeom>
+          <a:blipFill>
+            <a:blip>
+              <a:extLst>
+                <a:ext uri="{96DAC541-7B7A-43D3-8B79-37D633B846F1}">
+                  <asvg:svgBlip xmlns:asvg="http://schemas.microsoft.com/office/drawing/2016/SVG/main" r:embed="rId3"/>
+                </a:ext>
+              </a:extLst>
+            </a:blip>
+            <a:stretch>
+              <a:fillRect/>
+            </a:stretch>
+          </a:blipFill>
+        </p:spPr>
+      </p:sp>
+      <p:sp>
+        <p:nvSpPr>
+          <p:cNvPr id="4" name="Freeform 4"/>
+          <p:cNvSpPr/>
+          <p:nvPr/>
+        </p:nvSpPr>
+        <p:spPr>
+          <a:xfrm>
+            <a:off x="27223" y="159"/>
+            <a:ext cx="2356675" cy="6853098"/>
+          </a:xfrm>
+          <a:custGeom>
+            <a:avLst/>
+            <a:gdLst/>
+            <a:ahLst/>
+            <a:cxnLst/>
+            <a:rect l="l" t="t" r="r" b="b"/>
+            <a:pathLst>
+              <a:path w="3535013" h="10279647">
+                <a:moveTo>
+                  <a:pt x="0" y="0"/>
+                </a:moveTo>
+                <a:lnTo>
+                  <a:pt x="3535013" y="0"/>
+                </a:lnTo>
+                <a:lnTo>
+                  <a:pt x="3535013" y="10279647"/>
+                </a:lnTo>
+                <a:lnTo>
+                  <a:pt x="0" y="10279647"/>
+                </a:lnTo>
+                <a:lnTo>
+                  <a:pt x="0" y="0"/>
+                </a:lnTo>
+                <a:close/>
+              </a:path>
+            </a:pathLst>
+          </a:custGeom>
+          <a:blipFill>
+            <a:blip>
+              <a:extLst>
+                <a:ext uri="{96DAC541-7B7A-43D3-8B79-37D633B846F1}">
+                  <asvg:svgBlip xmlns:asvg="http://schemas.microsoft.com/office/drawing/2016/SVG/main" r:embed="rId4"/>
+                </a:ext>
+              </a:extLst>
+            </a:blip>
+            <a:stretch>
+              <a:fillRect/>
+            </a:stretch>
+          </a:blipFill>
+        </p:spPr>
+      </p:sp>
+      <p:grpSp>
+        <p:nvGrpSpPr>
+          <p:cNvPr id="5" name="Group 5"/>
+          <p:cNvGrpSpPr/>
+          <p:nvPr/>
+        </p:nvGrpSpPr>
+        <p:grpSpPr>
+          <a:xfrm>
+            <a:off x="0" y="0"/>
+            <a:ext cx="182880" cy="6858000"/>
+            <a:chOff x="0" y="0"/>
+            <a:chExt cx="243840" cy="9144000"/>
+          </a:xfrm>
+        </p:grpSpPr>
+        <p:sp>
+          <p:nvSpPr>
+            <p:cNvPr id="6" name="Freeform 6"/>
+            <p:cNvSpPr/>
+            <p:nvPr/>
+          </p:nvSpPr>
+          <p:spPr>
+            <a:xfrm>
+              <a:off x="0" y="0"/>
+              <a:ext cx="243840" cy="9144000"/>
+            </a:xfrm>
+            <a:custGeom>
+              <a:avLst/>
+              <a:gdLst/>
+              <a:ahLst/>
+              <a:cxnLst/>
+              <a:rect l="l" t="t" r="r" b="b"/>
+              <a:pathLst>
+                <a:path w="365760" h="13716000">
+                  <a:moveTo>
+                    <a:pt x="0" y="0"/>
+                  </a:moveTo>
+                  <a:lnTo>
+                    <a:pt x="365760" y="0"/>
+                  </a:lnTo>
+                  <a:lnTo>
+                    <a:pt x="365760" y="13716000"/>
+                  </a:lnTo>
+                  <a:lnTo>
+                    <a:pt x="0" y="13716000"/>
+                  </a:lnTo>
+                  <a:close/>
+                </a:path>
+              </a:pathLst>
+            </a:custGeom>
+            <a:solidFill>
+              <a:srgbClr val="2E5369"/>
+            </a:solidFill>
+          </p:spPr>
+        </p:sp>
+      </p:grpSp>
+      <p:grpSp>
+        <p:nvGrpSpPr>
+          <p:cNvPr id="7" name="Group 7"/>
+          <p:cNvGrpSpPr/>
+          <p:nvPr/>
+        </p:nvGrpSpPr>
+        <p:grpSpPr>
+          <a:xfrm>
+            <a:off x="0" y="4323810"/>
+            <a:ext cx="1744650" cy="778586"/>
+            <a:chOff x="0" y="0"/>
+            <a:chExt cx="2326200" cy="1038115"/>
+          </a:xfrm>
+        </p:grpSpPr>
+        <p:sp>
+          <p:nvSpPr>
+            <p:cNvPr id="8" name="Freeform 8"/>
+            <p:cNvSpPr/>
+            <p:nvPr/>
+          </p:nvSpPr>
+          <p:spPr>
+            <a:xfrm>
+              <a:off x="0" y="0"/>
+              <a:ext cx="2323084" cy="1038098"/>
+            </a:xfrm>
+            <a:custGeom>
+              <a:avLst/>
+              <a:gdLst/>
+              <a:ahLst/>
+              <a:cxnLst/>
+              <a:rect l="l" t="t" r="r" b="b"/>
+              <a:pathLst>
+                <a:path w="3484626" h="1557147">
+                  <a:moveTo>
+                    <a:pt x="2692019" y="1557147"/>
+                  </a:moveTo>
+                  <a:cubicBezTo>
+                    <a:pt x="2720213" y="1557147"/>
+                    <a:pt x="2738882" y="1547749"/>
+                    <a:pt x="2748280" y="1538351"/>
+                  </a:cubicBezTo>
+                  <a:cubicBezTo>
+                    <a:pt x="2748280" y="1528953"/>
+                    <a:pt x="2757678" y="1528953"/>
+                    <a:pt x="2757678" y="1528953"/>
+                  </a:cubicBezTo>
+                  <a:cubicBezTo>
+                    <a:pt x="3470529" y="815975"/>
+                    <a:pt x="3470529" y="815975"/>
+                    <a:pt x="3470529" y="815975"/>
+                  </a:cubicBezTo>
+                  <a:cubicBezTo>
+                    <a:pt x="3489325" y="797179"/>
+                    <a:pt x="3489325" y="759714"/>
+                    <a:pt x="3470529" y="731520"/>
+                  </a:cubicBezTo>
+                  <a:cubicBezTo>
+                    <a:pt x="2757678" y="27940"/>
+                    <a:pt x="2757678" y="27940"/>
+                    <a:pt x="2757678" y="27940"/>
+                  </a:cubicBezTo>
+                  <a:cubicBezTo>
+                    <a:pt x="2757678" y="18542"/>
+                    <a:pt x="2748280" y="18542"/>
+                    <a:pt x="2748280" y="18542"/>
+                  </a:cubicBezTo>
+                  <a:cubicBezTo>
+                    <a:pt x="2738882" y="9398"/>
+                    <a:pt x="2720213" y="0"/>
+                    <a:pt x="2692019" y="0"/>
+                  </a:cubicBezTo>
+                  <a:cubicBezTo>
+                    <a:pt x="0" y="0"/>
+                    <a:pt x="0" y="0"/>
+                    <a:pt x="0" y="0"/>
+                  </a:cubicBezTo>
+                  <a:cubicBezTo>
+                    <a:pt x="0" y="1557147"/>
+                    <a:pt x="0" y="1557147"/>
+                    <a:pt x="0" y="1557147"/>
+                  </a:cubicBezTo>
+                  <a:lnTo>
+                    <a:pt x="2692019" y="1557147"/>
+                  </a:lnTo>
+                  <a:close/>
+                </a:path>
+              </a:pathLst>
+            </a:custGeom>
+            <a:solidFill>
+              <a:srgbClr val="353535"/>
+            </a:solidFill>
+          </p:spPr>
+        </p:sp>
+      </p:grpSp>
+      <p:grpSp>
+        <p:nvGrpSpPr>
+          <p:cNvPr id="9" name="Group 9"/>
+          <p:cNvGrpSpPr/>
+          <p:nvPr/>
+        </p:nvGrpSpPr>
+        <p:grpSpPr>
+          <a:xfrm>
+            <a:off x="2963595" y="638534"/>
+            <a:ext cx="10029507" cy="1442085"/>
+            <a:chOff x="0" y="-12700"/>
+            <a:chExt cx="13372677" cy="1922780"/>
+          </a:xfrm>
+        </p:grpSpPr>
+        <p:sp>
+          <p:nvSpPr>
+            <p:cNvPr id="10" name="Freeform 10"/>
+            <p:cNvSpPr/>
+            <p:nvPr/>
+          </p:nvSpPr>
+          <p:spPr>
+            <a:xfrm>
+              <a:off x="0" y="0"/>
+              <a:ext cx="13372677" cy="1910080"/>
+            </a:xfrm>
+            <a:custGeom>
+              <a:avLst/>
+              <a:gdLst/>
+              <a:ahLst/>
+              <a:cxnLst/>
+              <a:rect l="l" t="t" r="r" b="b"/>
+              <a:pathLst>
+                <a:path w="20059014" h="2865120">
+                  <a:moveTo>
+                    <a:pt x="0" y="0"/>
+                  </a:moveTo>
+                  <a:lnTo>
+                    <a:pt x="20059014" y="0"/>
+                  </a:lnTo>
+                  <a:lnTo>
+                    <a:pt x="20059014" y="2865120"/>
+                  </a:lnTo>
+                  <a:lnTo>
+                    <a:pt x="0" y="2865120"/>
+                  </a:lnTo>
+                  <a:close/>
+                </a:path>
+              </a:pathLst>
+            </a:custGeom>
+            <a:blipFill>
+              <a:blip r:embed="rId5">
+                <a:alphaModFix amt="0"/>
+              </a:blip>
+              <a:stretch>
+                <a:fillRect t="-86416" b="-86416"/>
+              </a:stretch>
+            </a:blipFill>
+          </p:spPr>
+        </p:sp>
+        <p:sp>
+          <p:nvSpPr>
+            <p:cNvPr id="11" name="TextBox 11"/>
+            <p:cNvSpPr txBox="1"/>
+            <p:nvPr/>
+          </p:nvSpPr>
+          <p:spPr>
+            <a:xfrm>
+              <a:off x="0" y="-12700"/>
+              <a:ext cx="13372677" cy="1922780"/>
+            </a:xfrm>
+            <a:prstGeom prst="rect">
+              <a:avLst/>
+            </a:prstGeom>
+          </p:spPr>
+          <p:txBody>
+            <a:bodyPr lIns="0" tIns="0" rIns="0" bIns="0" rtlCol="0" anchor="b"/>
+            <a:lstStyle/>
+            <a:p>
+              <a:pPr algn="l">
+                <a:lnSpc>
+                  <a:spcPts val="2400"/>
+                </a:lnSpc>
+              </a:pPr>
+              <a:r>
+                <a:rPr lang="en-US" sz="2000" b="1" dirty="0">
+                  <a:solidFill>
+                    <a:srgbClr val="178DBB"/>
+                  </a:solidFill>
+                  <a:latin typeface="Times New Roman"/>
+                  <a:ea typeface="Times New Roman"/>
+                  <a:cs typeface="Times New Roman"/>
+                  <a:sym typeface="Times New Roman"/>
+                </a:rPr>
+                <a:t>            </a:t>
+              </a:r>
+              <a:r>
+                <a:rPr lang="en-US" sz="2000" b="1" dirty="0">
+                  <a:solidFill>
+                    <a:srgbClr val="000000"/>
+                  </a:solidFill>
+                  <a:latin typeface="Times New Roman"/>
+                  <a:ea typeface="Times New Roman"/>
+                  <a:cs typeface="Times New Roman"/>
+                  <a:sym typeface="Times New Roman"/>
+                </a:rPr>
+                <a:t>EASWARI ENGINEERING COLLEGE</a:t>
+              </a:r>
+            </a:p>
+            <a:p>
+              <a:pPr algn="l">
+                <a:lnSpc>
+                  <a:spcPts val="3439"/>
+                </a:lnSpc>
+              </a:pPr>
+              <a:endParaRPr lang="en-US" sz="2000" b="1" dirty="0">
+                <a:solidFill>
+                  <a:srgbClr val="000000"/>
+                </a:solidFill>
+                <a:latin typeface="Times New Roman"/>
+                <a:ea typeface="Times New Roman"/>
+                <a:cs typeface="Times New Roman"/>
+                <a:sym typeface="Times New Roman"/>
+              </a:endParaRPr>
+            </a:p>
+          </p:txBody>
+        </p:sp>
+      </p:grpSp>
+      <p:sp>
+        <p:nvSpPr>
+          <p:cNvPr id="12" name="TextBox 12"/>
+          <p:cNvSpPr txBox="1"/>
+          <p:nvPr/>
+        </p:nvSpPr>
+        <p:spPr>
+          <a:xfrm>
+            <a:off x="2124393" y="2183130"/>
+            <a:ext cx="8793480" cy="2635250"/>
+          </a:xfrm>
+          <a:prstGeom prst="rect">
+            <a:avLst/>
+          </a:prstGeom>
+        </p:spPr>
+        <p:txBody>
+          <a:bodyPr lIns="0" tIns="0" rIns="0" bIns="0" rtlCol="0" anchor="t">
+            <a:spAutoFit/>
+          </a:bodyPr>
+          <a:lstStyle/>
+          <a:p>
+            <a:pPr algn="ctr">
+              <a:lnSpc>
+                <a:spcPts val="3360"/>
+              </a:lnSpc>
+            </a:pPr>
+            <a:r>
+              <a:rPr lang="en-US" sz="2800" b="1" dirty="0">
+                <a:solidFill>
+                  <a:srgbClr val="595959"/>
+                </a:solidFill>
+                <a:latin typeface="Times New Roman"/>
+                <a:ea typeface="Times New Roman"/>
+                <a:cs typeface="Times New Roman"/>
+                <a:sym typeface="Times New Roman"/>
+              </a:rPr>
+              <a:t>AI-Based News Credibility and Misinformation Detection System</a:t>
+            </a:r>
+          </a:p>
+          <a:p>
+            <a:pPr algn="l">
+              <a:lnSpc>
+                <a:spcPts val="2400"/>
+              </a:lnSpc>
+            </a:pPr>
+            <a:endParaRPr lang="en-US" sz="2800" b="1" dirty="0">
+              <a:solidFill>
+                <a:srgbClr val="595959"/>
+              </a:solidFill>
+              <a:latin typeface="Times New Roman"/>
+              <a:ea typeface="Times New Roman"/>
+              <a:cs typeface="Times New Roman"/>
+              <a:sym typeface="Times New Roman"/>
+            </a:endParaRPr>
+          </a:p>
+          <a:p>
+            <a:pPr algn="l">
+              <a:lnSpc>
+                <a:spcPts val="2160"/>
+              </a:lnSpc>
+            </a:pPr>
+            <a:r>
+              <a:rPr lang="en-US" sz="1800" dirty="0">
+                <a:solidFill>
+                  <a:srgbClr val="595959"/>
+                </a:solidFill>
+                <a:latin typeface="Times New Roman"/>
+                <a:ea typeface="Times New Roman"/>
+                <a:cs typeface="Times New Roman"/>
+                <a:sym typeface="Times New Roman"/>
+              </a:rPr>
+              <a:t> </a:t>
+            </a:r>
+          </a:p>
+          <a:p>
+            <a:pPr algn="l">
+              <a:lnSpc>
+                <a:spcPts val="2160"/>
+              </a:lnSpc>
+            </a:pPr>
+            <a:r>
+              <a:rPr lang="en-US" sz="1800" b="1" dirty="0">
+                <a:solidFill>
+                  <a:srgbClr val="595959"/>
+                </a:solidFill>
+                <a:latin typeface="Times New Roman"/>
+                <a:ea typeface="Times New Roman"/>
+                <a:cs typeface="Times New Roman"/>
+                <a:sym typeface="Times New Roman"/>
+              </a:rPr>
+              <a:t>Under the Guidance of                                    Presented By</a:t>
+            </a:r>
+          </a:p>
+          <a:p>
+            <a:pPr algn="l">
+              <a:lnSpc>
+                <a:spcPts val="2160"/>
+              </a:lnSpc>
+            </a:pPr>
+            <a:r>
+              <a:rPr lang="en-US" sz="1800" b="1" dirty="0">
+                <a:solidFill>
+                  <a:srgbClr val="595959"/>
+                </a:solidFill>
+                <a:latin typeface="Times New Roman"/>
+                <a:ea typeface="Times New Roman"/>
+                <a:cs typeface="Times New Roman"/>
+                <a:sym typeface="Times New Roman"/>
+              </a:rPr>
+              <a:t>  Ms. D S K Harshitha                                       </a:t>
+            </a:r>
+            <a:r>
+              <a:rPr lang="en-US" sz="1800" dirty="0">
+                <a:solidFill>
+                  <a:srgbClr val="595959"/>
+                </a:solidFill>
+                <a:latin typeface="Times New Roman"/>
+                <a:ea typeface="Times New Roman"/>
+                <a:cs typeface="Times New Roman"/>
+                <a:sym typeface="Times New Roman"/>
+              </a:rPr>
+              <a:t>Sanjay G (310624243159)</a:t>
+            </a:r>
+          </a:p>
+          <a:p>
+            <a:pPr algn="l">
+              <a:lnSpc>
+                <a:spcPts val="2160"/>
+              </a:lnSpc>
+            </a:pPr>
+            <a:r>
+              <a:rPr lang="en-US" sz="1800" dirty="0">
+                <a:solidFill>
+                  <a:srgbClr val="595959"/>
+                </a:solidFill>
+                <a:latin typeface="Times New Roman"/>
+                <a:ea typeface="Times New Roman"/>
+                <a:cs typeface="Times New Roman"/>
+                <a:sym typeface="Times New Roman"/>
+              </a:rPr>
+              <a:t>  Technical Trainer, AIADS </a:t>
+            </a:r>
+          </a:p>
+        </p:txBody>
+      </p:sp>
+      <p:grpSp>
+        <p:nvGrpSpPr>
+          <p:cNvPr id="13" name="Group 13"/>
+          <p:cNvGrpSpPr/>
+          <p:nvPr/>
+        </p:nvGrpSpPr>
+        <p:grpSpPr>
+          <a:xfrm>
+            <a:off x="1839214" y="712457"/>
+            <a:ext cx="1499997" cy="1303763"/>
+            <a:chOff x="0" y="0"/>
+            <a:chExt cx="1999996" cy="1738351"/>
+          </a:xfrm>
+        </p:grpSpPr>
+        <p:sp>
+          <p:nvSpPr>
+            <p:cNvPr id="14" name="Freeform 14"/>
+            <p:cNvSpPr/>
+            <p:nvPr/>
+          </p:nvSpPr>
+          <p:spPr>
+            <a:xfrm>
+              <a:off x="0" y="0"/>
+              <a:ext cx="1999996" cy="1738376"/>
+            </a:xfrm>
+            <a:custGeom>
+              <a:avLst/>
+              <a:gdLst/>
+              <a:ahLst/>
+              <a:cxnLst/>
+              <a:rect l="l" t="t" r="r" b="b"/>
+              <a:pathLst>
+                <a:path w="2999994" h="2607564">
+                  <a:moveTo>
+                    <a:pt x="0" y="0"/>
+                  </a:moveTo>
+                  <a:lnTo>
+                    <a:pt x="2999994" y="0"/>
+                  </a:lnTo>
+                  <a:lnTo>
+                    <a:pt x="2999994" y="2607564"/>
+                  </a:lnTo>
+                  <a:lnTo>
+                    <a:pt x="0" y="2607564"/>
+                  </a:lnTo>
+                  <a:lnTo>
+                    <a:pt x="0" y="0"/>
+                  </a:lnTo>
+                  <a:close/>
+                </a:path>
+              </a:pathLst>
+            </a:custGeom>
+            <a:blipFill>
+              <a:blip r:embed="rId6"/>
+              <a:stretch>
+                <a:fillRect l="-18" r="-18" b="1"/>
+              </a:stretch>
+            </a:blipFill>
+          </p:spPr>
+        </p:sp>
+      </p:grpSp>
+    </p:spTree>
+    <p:extLst>
+      <p:ext uri="{BB962C8B-B14F-4D97-AF65-F5344CB8AC3E}">
+        <p14:creationId xmlns:p14="http://schemas.microsoft.com/office/powerpoint/2010/main" val="1071395717"/>
+      </p:ext>
+    </p:extLst>
+  </p:cSld>
+  <p:clrMapOvr>
+    <a:masterClrMapping/>
+  </p:clrMapOvr>
+</p:sld>
+</file>
+
+<file path=ppt/slides/slide10.xml><?xml version="1.0" encoding="utf-8"?>
+<p:sld xmlns:a="http://schemas.openxmlformats.org/drawingml/2006/main" xmlns:r="http://schemas.openxmlformats.org/officeDocument/2006/relationships" xmlns:p="http://schemas.openxmlformats.org/presentationml/2006/main">
+  <p:cSld name="Slide 10">
     <p:bg>
       <p:bgPr>
         <a:solidFill>
@@ -2020,7 +2787,77 @@
       </p:grpSpPr>
       <p:sp>
         <p:nvSpPr>
-          <p:cNvPr id="2" name="Text 0"/>
+          <p:cNvPr id="2" name="Shape 0"/>
+          <p:cNvSpPr/>
+          <p:nvPr/>
+        </p:nvSpPr>
+        <p:spPr>
+          <a:xfrm>
+            <a:off x="457200" y="457200"/>
+            <a:ext cx="502920" cy="502920"/>
+          </a:xfrm>
+          <a:prstGeom prst="ellipse">
+            <a:avLst/>
+          </a:prstGeom>
+          <a:solidFill>
+            <a:srgbClr val="00A896"/>
+          </a:solidFill>
+          <a:ln/>
+        </p:spPr>
+        <p:txBody>
+          <a:bodyPr/>
+          <a:lstStyle/>
+          <a:p>
+            <a:endParaRPr/>
+          </a:p>
+        </p:txBody>
+      </p:sp>
+      <p:sp>
+        <p:nvSpPr>
+          <p:cNvPr id="3" name="Text 1"/>
+          <p:cNvSpPr txBox="1"/>
+          <p:nvPr/>
+        </p:nvSpPr>
+        <p:spPr>
+          <a:xfrm>
+            <a:off x="457200" y="457200"/>
+            <a:ext cx="502920" cy="502920"/>
+          </a:xfrm>
+          <a:prstGeom prst="rect">
+            <a:avLst/>
+          </a:prstGeom>
+          <a:noFill/>
+          <a:ln/>
+        </p:spPr>
+        <p:txBody>
+          <a:bodyPr wrap="square" lIns="0" tIns="0" rIns="0" bIns="0" rtlCol="0" anchor="ctr"/>
+          <a:lstStyle/>
+          <a:p>
+            <a:pPr marL="0" indent="0" algn="ctr">
+              <a:buNone/>
+            </a:pPr>
+            <a:r>
+              <a:rPr lang="en-US" sz="1800" b="1" dirty="0">
+                <a:solidFill>
+                  <a:srgbClr val="FFFFFF"/>
+                </a:solidFill>
+                <a:latin typeface="Times New Roman"/>
+                <a:ea typeface="Times New Roman"/>
+                <a:cs typeface="Times New Roman"/>
+              </a:rPr>
+              <a:t>08</a:t>
+            </a:r>
+            <a:endParaRPr lang="en-US" sz="1800" b="1" dirty="0">
+              <a:latin typeface="Times New Roman"/>
+              <a:ea typeface="Times New Roman"/>
+              <a:cs typeface="Times New Roman"/>
+            </a:endParaRPr>
+          </a:p>
+        </p:txBody>
+      </p:sp>
+      <p:sp>
+        <p:nvSpPr>
+          <p:cNvPr id="4" name="Text 2"/>
           <p:cNvSpPr txBox="1"/>
           <p:nvPr/>
         </p:nvSpPr>
@@ -2051,7 +2888,7 @@
                 <a:ea typeface="Times New Roman"/>
                 <a:cs typeface="Times New Roman"/>
               </a:rPr>
-              <a:t>AGENDA</a:t>
+              <a:t>FRONTEND</a:t>
             </a:r>
             <a:endParaRPr lang="en-US" sz="2000" dirty="0">
               <a:latin typeface="Times New Roman"/>
@@ -2063,14 +2900,14 @@
       </p:sp>
       <p:sp>
         <p:nvSpPr>
-          <p:cNvPr id="3" name="Text 1"/>
+          <p:cNvPr id="5" name="Text 3"/>
           <p:cNvSpPr txBox="1"/>
           <p:nvPr/>
         </p:nvSpPr>
         <p:spPr>
           <a:xfrm>
             <a:off x="1097280" y="713232"/>
-            <a:ext cx="10058400" cy="548640"/>
+            <a:ext cx="10515600" cy="548640"/>
           </a:xfrm>
           <a:prstGeom prst="rect">
             <a:avLst/>
@@ -2094,19 +2931,19 @@
                 <a:ea typeface="Times New Roman"/>
                 <a:cs typeface="Times New Roman"/>
               </a:rPr>
-              <a:t>Scope of This Review</a:t>
-            </a:r>
-            <a:endParaRPr lang="en-US" sz="2800" dirty="0" b="1">
-              <a:latin typeface="Times New Roman"/>
-              <a:ea typeface="Times New Roman"/>
-              <a:cs typeface="Times New Roman"/>
-            </a:endParaRPr>
-          </a:p>
-        </p:txBody>
-      </p:sp>
-      <p:sp>
-        <p:nvSpPr>
-          <p:cNvPr id="4" name="Shape 2"/>
+              <a:t>Frontend Development</a:t>
+            </a:r>
+            <a:endParaRPr lang="en-US" sz="2800" b="1" dirty="0">
+              <a:latin typeface="Times New Roman"/>
+              <a:ea typeface="Times New Roman"/>
+              <a:cs typeface="Times New Roman"/>
+            </a:endParaRPr>
+          </a:p>
+        </p:txBody>
+      </p:sp>
+      <p:sp>
+        <p:nvSpPr>
+          <p:cNvPr id="6" name="Shape 4"/>
           <p:cNvSpPr/>
           <p:nvPr/>
         </p:nvSpPr>
@@ -2128,45 +2965,22 @@
         </p:spPr>
         <p:txBody>
           <a:bodyPr/>
-          <a:p/>
-        </p:txBody>
-      </p:sp>
-      <p:sp>
-        <p:nvSpPr>
-          <p:cNvPr id="8" name="Shape 6"/>
-          <p:cNvSpPr/>
-          <p:nvPr/>
-        </p:nvSpPr>
-        <p:spPr>
-          <a:xfrm>
-            <a:off x="998144" y="1700059"/>
-            <a:ext cx="5029200" cy="3713907"/>
-          </a:xfrm>
-          <a:prstGeom prst="roundRect">
-            <a:avLst>
-              <a:gd name="adj" fmla="val 1778"/>
-            </a:avLst>
-          </a:prstGeom>
-          <a:solidFill>
-            <a:srgbClr val="028090"/>
-          </a:solidFill>
-          <a:ln/>
-        </p:spPr>
-        <p:txBody>
-          <a:bodyPr/>
-          <a:p/>
-        </p:txBody>
-      </p:sp>
-      <p:sp>
-        <p:nvSpPr>
-          <p:cNvPr id="10" name="Text 8"/>
+          <a:lstStyle/>
+          <a:p>
+            <a:endParaRPr/>
+          </a:p>
+        </p:txBody>
+      </p:sp>
+      <p:sp>
+        <p:nvSpPr>
+          <p:cNvPr id="7" name="Text 5"/>
           <p:cNvSpPr txBox="1"/>
           <p:nvPr/>
         </p:nvSpPr>
         <p:spPr>
           <a:xfrm>
-            <a:off x="1371600" y="2130643"/>
-            <a:ext cx="4572000" cy="2814903"/>
+            <a:off x="1097280" y="702129"/>
+            <a:ext cx="9875520" cy="4206240"/>
           </a:xfrm>
           <a:prstGeom prst="rect">
             <a:avLst/>
@@ -2188,13 +3002,13 @@
             <a:r>
               <a:rPr lang="en-US" sz="1800" dirty="0">
                 <a:solidFill>
-                  <a:srgbClr val="FFFFFF"/>
-                </a:solidFill>
-                <a:latin typeface="Times New Roman"/>
-                <a:ea typeface="Times New Roman"/>
-                <a:cs typeface="Times New Roman"/>
-              </a:rPr>
-              <a:t>Requirements (Functional &amp; NFR)</a:t>
+                  <a:srgbClr val="1B2A2E"/>
+                </a:solidFill>
+                <a:latin typeface="Times New Roman"/>
+                <a:ea typeface="Times New Roman"/>
+                <a:cs typeface="Times New Roman"/>
+              </a:rPr>
+              <a:t>React 18 + Vite 5 with functional components and hooks (64 JSX files)</a:t>
             </a:r>
             <a:endParaRPr lang="en-US" sz="1800" dirty="0">
               <a:latin typeface="Times New Roman"/>
@@ -2213,13 +3027,13 @@
             <a:r>
               <a:rPr lang="en-US" sz="1800" dirty="0">
                 <a:solidFill>
-                  <a:srgbClr val="FFFFFF"/>
-                </a:solidFill>
-                <a:latin typeface="Times New Roman"/>
-                <a:ea typeface="Times New Roman"/>
-                <a:cs typeface="Times New Roman"/>
-              </a:rPr>
-              <a:t>Detailed System Architecture</a:t>
+                  <a:srgbClr val="1B2A2E"/>
+                </a:solidFill>
+                <a:latin typeface="Times New Roman"/>
+                <a:ea typeface="Times New Roman"/>
+                <a:cs typeface="Times New Roman"/>
+              </a:rPr>
+              <a:t>React Router: 25 routes across public, auth, user and admin areas</a:t>
             </a:r>
             <a:endParaRPr lang="en-US" sz="1800" dirty="0">
               <a:latin typeface="Times New Roman"/>
@@ -2238,13 +3052,13 @@
             <a:r>
               <a:rPr lang="en-US" sz="1800" dirty="0">
                 <a:solidFill>
-                  <a:srgbClr val="FFFFFF"/>
-                </a:solidFill>
-                <a:latin typeface="Times New Roman"/>
-                <a:ea typeface="Times New Roman"/>
-                <a:cs typeface="Times New Roman"/>
-              </a:rPr>
-              <a:t>Use Case &amp; ER Diagrams</a:t>
+                  <a:srgbClr val="1B2A2E"/>
+                </a:solidFill>
+                <a:latin typeface="Times New Roman"/>
+                <a:ea typeface="Times New Roman"/>
+                <a:cs typeface="Times New Roman"/>
+              </a:rPr>
+              <a:t>Context API for auth and theme; Axios client with JWT interceptor</a:t>
             </a:r>
             <a:endParaRPr lang="en-US" sz="1800" dirty="0">
               <a:latin typeface="Times New Roman"/>
@@ -2263,13 +3077,13 @@
             <a:r>
               <a:rPr lang="en-US" sz="1800" dirty="0">
                 <a:solidFill>
-                  <a:srgbClr val="FFFFFF"/>
-                </a:solidFill>
-                <a:latin typeface="Times New Roman"/>
-                <a:ea typeface="Times New Roman"/>
-                <a:cs typeface="Times New Roman"/>
-              </a:rPr>
-              <a:t>Module Description &amp; Tech Stack</a:t>
+                  <a:srgbClr val="1B2A2E"/>
+                </a:solidFill>
+                <a:latin typeface="Times New Roman"/>
+                <a:ea typeface="Times New Roman"/>
+                <a:cs typeface="Times New Roman"/>
+              </a:rPr>
+              <a:t>Analyze page: link or paste mode, live progress over Socket.IO</a:t>
             </a:r>
             <a:endParaRPr lang="en-US" sz="1800" dirty="0">
               <a:latin typeface="Times New Roman"/>
@@ -2288,13 +3102,13 @@
             <a:r>
               <a:rPr lang="en-US" sz="1800" dirty="0">
                 <a:solidFill>
-                  <a:srgbClr val="FFFFFF"/>
-                </a:solidFill>
-                <a:latin typeface="Times New Roman"/>
-                <a:ea typeface="Times New Roman"/>
-                <a:cs typeface="Times New Roman"/>
-              </a:rPr>
-              <a:t>UI Design, Frontend &amp; Backend Build</a:t>
+                  <a:srgbClr val="1B2A2E"/>
+                </a:solidFill>
+                <a:latin typeface="Times New Roman"/>
+                <a:ea typeface="Times New Roman"/>
+                <a:cs typeface="Times New Roman"/>
+              </a:rPr>
+              <a:t>Report page: score ring, factor bars, caps, confidence, claims, PDF</a:t>
             </a:r>
             <a:endParaRPr lang="en-US" sz="1800" dirty="0">
               <a:latin typeface="Times New Roman"/>
@@ -2313,13 +3127,13 @@
             <a:r>
               <a:rPr lang="en-US" sz="1800" dirty="0">
                 <a:solidFill>
-                  <a:srgbClr val="FFFFFF"/>
-                </a:solidFill>
-                <a:latin typeface="Times New Roman"/>
-                <a:ea typeface="Times New Roman"/>
-                <a:cs typeface="Times New Roman"/>
-              </a:rPr>
-              <a:t>Database &amp; API Integration</a:t>
+                  <a:srgbClr val="1B2A2E"/>
+                </a:solidFill>
+                <a:latin typeface="Times New Roman"/>
+                <a:ea typeface="Times New Roman"/>
+                <a:cs typeface="Times New Roman"/>
+              </a:rPr>
+              <a:t>Bootstrap 5 with custom design tokens, light and dark mode</a:t>
             </a:r>
             <a:endParaRPr lang="en-US" sz="1800" dirty="0">
               <a:latin typeface="Times New Roman"/>
@@ -2338,13 +3152,13 @@
             <a:r>
               <a:rPr lang="en-US" sz="1800" dirty="0">
                 <a:solidFill>
-                  <a:srgbClr val="FFFFFF"/>
-                </a:solidFill>
-                <a:latin typeface="Times New Roman"/>
-                <a:ea typeface="Times New Roman"/>
-                <a:cs typeface="Times New Roman"/>
-              </a:rPr>
-              <a:t>Progress (94%), Screenshots &amp; Challenges</a:t>
+                  <a:srgbClr val="1B2A2E"/>
+                </a:solidFill>
+                <a:latin typeface="Times New Roman"/>
+                <a:ea typeface="Times New Roman"/>
+                <a:cs typeface="Times New Roman"/>
+              </a:rPr>
+              <a:t>Chart.js dashboards; admin and report pages lazy-loaded</a:t>
             </a:r>
             <a:endParaRPr lang="en-US" sz="1800" dirty="0">
               <a:latin typeface="Times New Roman"/>
@@ -2356,7 +3170,84 @@
       </p:sp>
       <p:sp>
         <p:nvSpPr>
-          <p:cNvPr id="11" name="Text 9"/>
+          <p:cNvPr id="8" name="Shape 6"/>
+          <p:cNvSpPr/>
+          <p:nvPr/>
+        </p:nvSpPr>
+        <p:spPr>
+          <a:xfrm>
+            <a:off x="1097280" y="5623560"/>
+            <a:ext cx="9966960" cy="594360"/>
+          </a:xfrm>
+          <a:prstGeom prst="roundRect">
+            <a:avLst>
+              <a:gd name="adj" fmla="val 12308"/>
+            </a:avLst>
+          </a:prstGeom>
+          <a:solidFill>
+            <a:srgbClr val="F4FAF9"/>
+          </a:solidFill>
+          <a:ln w="12700">
+            <a:solidFill>
+              <a:srgbClr val="D7E7E5"/>
+            </a:solidFill>
+            <a:prstDash val="solid"/>
+          </a:ln>
+        </p:spPr>
+        <p:txBody>
+          <a:bodyPr/>
+          <a:lstStyle/>
+          <a:p>
+            <a:endParaRPr/>
+          </a:p>
+        </p:txBody>
+      </p:sp>
+      <p:sp>
+        <p:nvSpPr>
+          <p:cNvPr id="9" name="Text 7"/>
+          <p:cNvSpPr txBox="1"/>
+          <p:nvPr/>
+        </p:nvSpPr>
+        <p:spPr>
+          <a:xfrm>
+            <a:off x="1325880" y="5623560"/>
+            <a:ext cx="9509760" cy="594360"/>
+          </a:xfrm>
+          <a:prstGeom prst="rect">
+            <a:avLst/>
+          </a:prstGeom>
+          <a:noFill/>
+          <a:ln/>
+        </p:spPr>
+        <p:txBody>
+          <a:bodyPr wrap="square" lIns="0" tIns="0" rIns="0" bIns="0" rtlCol="0" anchor="ctr"/>
+          <a:lstStyle/>
+          <a:p>
+            <a:pPr marL="0" indent="0">
+              <a:buNone/>
+            </a:pPr>
+            <a:r>
+              <a:rPr lang="en-US" sz="1800" i="1" dirty="0">
+                <a:solidFill>
+                  <a:srgbClr val="3E5C58"/>
+                </a:solidFill>
+                <a:latin typeface="Times New Roman"/>
+                <a:ea typeface="Times New Roman"/>
+                <a:cs typeface="Times New Roman"/>
+              </a:rPr>
+              <a:t>Done: Landing, Login, Register, OTP, Reset, Dashboard, Analyze, Report, History, Saved, Sources, Notifications, Settings, 8 admin pages.</a:t>
+            </a:r>
+            <a:endParaRPr lang="en-US" sz="1800" dirty="0">
+              <a:latin typeface="Times New Roman"/>
+              <a:ea typeface="Times New Roman"/>
+              <a:cs typeface="Times New Roman"/>
+            </a:endParaRPr>
+          </a:p>
+        </p:txBody>
+      </p:sp>
+      <p:sp>
+        <p:nvSpPr>
+          <p:cNvPr id="10" name="Text 8"/>
           <p:cNvSpPr txBox="1"/>
           <p:nvPr/>
         </p:nvSpPr>
@@ -2387,7 +3278,7 @@
                 <a:ea typeface="Times New Roman"/>
                 <a:cs typeface="Times New Roman"/>
               </a:rPr>
-              <a:t>Agenda</a:t>
+              <a:t>Frontend</a:t>
             </a:r>
             <a:endParaRPr lang="en-US" sz="1800" dirty="0">
               <a:latin typeface="Times New Roman"/>
@@ -2399,7 +3290,7 @@
       </p:sp>
       <p:sp>
         <p:nvSpPr>
-          <p:cNvPr id="12" name="Text 10"/>
+          <p:cNvPr id="11" name="Text 9"/>
           <p:cNvSpPr txBox="1"/>
           <p:nvPr/>
         </p:nvSpPr>
@@ -2448,7 +3339,7 @@
 </p:sld>
 </file>
 
-<file path=ppt/slides/slide10.xml><?xml version="1.0" encoding="utf-8"?>
+<file path=ppt/slides/slide11.xml><?xml version="1.0" encoding="utf-8"?>
 <p:sld xmlns:a="http://schemas.openxmlformats.org/drawingml/2006/main" xmlns:r="http://schemas.openxmlformats.org/officeDocument/2006/relationships" xmlns:p="http://schemas.openxmlformats.org/presentationml/2006/main">
   <p:cSld name="Slide 11">
     <p:bg>
@@ -2494,7 +3385,10 @@
         </p:spPr>
         <p:txBody>
           <a:bodyPr/>
-          <a:p/>
+          <a:lstStyle/>
+          <a:p>
+            <a:endParaRPr/>
+          </a:p>
         </p:txBody>
       </p:sp>
       <p:sp>
@@ -2532,7 +3426,7 @@
               </a:rPr>
               <a:t>09</a:t>
             </a:r>
-            <a:endParaRPr lang="en-US" sz="1800" dirty="0" b="1">
+            <a:endParaRPr lang="en-US" sz="1800" b="1" dirty="0">
               <a:latin typeface="Times New Roman"/>
               <a:ea typeface="Times New Roman"/>
               <a:cs typeface="Times New Roman"/>
@@ -2618,7 +3512,7 @@
               </a:rPr>
               <a:t>Backend Development</a:t>
             </a:r>
-            <a:endParaRPr lang="en-US" sz="2800" dirty="0" b="1">
+            <a:endParaRPr lang="en-US" sz="2800" b="1" dirty="0">
               <a:latin typeface="Times New Roman"/>
               <a:ea typeface="Times New Roman"/>
               <a:cs typeface="Times New Roman"/>
@@ -2650,7 +3544,10 @@
         </p:spPr>
         <p:txBody>
           <a:bodyPr/>
-          <a:p/>
+          <a:lstStyle/>
+          <a:p>
+            <a:endParaRPr/>
+          </a:p>
         </p:txBody>
       </p:sp>
       <p:sp>
@@ -2661,7 +3558,7 @@
         </p:nvSpPr>
         <p:spPr>
           <a:xfrm>
-            <a:off x="1097280" y="1691640"/>
+            <a:off x="1097280" y="689532"/>
             <a:ext cx="9875520" cy="4206240"/>
           </a:xfrm>
           <a:prstGeom prst="rect">
@@ -2878,7 +3775,10 @@
         </p:spPr>
         <p:txBody>
           <a:bodyPr/>
-          <a:p/>
+          <a:lstStyle/>
+          <a:p>
+            <a:endParaRPr/>
+          </a:p>
         </p:txBody>
       </p:sp>
       <p:sp>
@@ -3018,7 +3918,7 @@
 </p:sld>
 </file>
 
-<file path=ppt/slides/slide11.xml><?xml version="1.0" encoding="utf-8"?>
+<file path=ppt/slides/slide12.xml><?xml version="1.0" encoding="utf-8"?>
 <p:sld xmlns:a="http://schemas.openxmlformats.org/drawingml/2006/main" xmlns:r="http://schemas.openxmlformats.org/officeDocument/2006/relationships" xmlns:p="http://schemas.openxmlformats.org/presentationml/2006/main">
   <p:cSld name="Slide 12">
     <p:bg>
@@ -3064,7 +3964,10 @@
         </p:spPr>
         <p:txBody>
           <a:bodyPr/>
-          <a:p/>
+          <a:lstStyle/>
+          <a:p>
+            <a:endParaRPr/>
+          </a:p>
         </p:txBody>
       </p:sp>
       <p:sp>
@@ -3102,7 +4005,7 @@
               </a:rPr>
               <a:t>10</a:t>
             </a:r>
-            <a:endParaRPr lang="en-US" sz="1800" dirty="0" b="1">
+            <a:endParaRPr lang="en-US" sz="1800" b="1" dirty="0">
               <a:latin typeface="Times New Roman"/>
               <a:ea typeface="Times New Roman"/>
               <a:cs typeface="Times New Roman"/>
@@ -3188,7 +4091,7 @@
               </a:rPr>
               <a:t>Database Integration</a:t>
             </a:r>
-            <a:endParaRPr lang="en-US" sz="2800" dirty="0" b="1">
+            <a:endParaRPr lang="en-US" sz="2800" b="1" dirty="0">
               <a:latin typeface="Times New Roman"/>
               <a:ea typeface="Times New Roman"/>
               <a:cs typeface="Times New Roman"/>
@@ -3220,7 +4123,10 @@
         </p:spPr>
         <p:txBody>
           <a:bodyPr/>
-          <a:p/>
+          <a:lstStyle/>
+          <a:p>
+            <a:endParaRPr/>
+          </a:p>
         </p:txBody>
       </p:sp>
       <p:sp>
@@ -3231,7 +4137,7 @@
         </p:nvSpPr>
         <p:spPr>
           <a:xfrm>
-            <a:off x="1097280" y="1691640"/>
+            <a:off x="1097280" y="708660"/>
             <a:ext cx="9875520" cy="4206240"/>
           </a:xfrm>
           <a:prstGeom prst="rect">
@@ -3448,7 +4354,10 @@
         </p:spPr>
         <p:txBody>
           <a:bodyPr/>
-          <a:p/>
+          <a:lstStyle/>
+          <a:p>
+            <a:endParaRPr/>
+          </a:p>
         </p:txBody>
       </p:sp>
       <p:sp>
@@ -3588,7 +4497,7 @@
 </p:sld>
 </file>
 
-<file path=ppt/slides/slide12.xml><?xml version="1.0" encoding="utf-8"?>
+<file path=ppt/slides/slide13.xml><?xml version="1.0" encoding="utf-8"?>
 <p:sld xmlns:a="http://schemas.openxmlformats.org/drawingml/2006/main" xmlns:r="http://schemas.openxmlformats.org/officeDocument/2006/relationships" xmlns:p="http://schemas.openxmlformats.org/presentationml/2006/main">
   <p:cSld name="Slide 13">
     <p:bg>
@@ -3634,7 +4543,10 @@
         </p:spPr>
         <p:txBody>
           <a:bodyPr/>
-          <a:p/>
+          <a:lstStyle/>
+          <a:p>
+            <a:endParaRPr/>
+          </a:p>
         </p:txBody>
       </p:sp>
       <p:sp>
@@ -3672,7 +4584,7 @@
               </a:rPr>
               <a:t>11</a:t>
             </a:r>
-            <a:endParaRPr lang="en-US" sz="1800" dirty="0" b="1">
+            <a:endParaRPr lang="en-US" sz="1800" b="1" dirty="0">
               <a:latin typeface="Times New Roman"/>
               <a:ea typeface="Times New Roman"/>
               <a:cs typeface="Times New Roman"/>
@@ -3758,7 +4670,7 @@
               </a:rPr>
               <a:t>API Development</a:t>
             </a:r>
-            <a:endParaRPr lang="en-US" sz="2800" dirty="0" b="1">
+            <a:endParaRPr lang="en-US" sz="2800" b="1" dirty="0">
               <a:latin typeface="Times New Roman"/>
               <a:ea typeface="Times New Roman"/>
               <a:cs typeface="Times New Roman"/>
@@ -3790,7 +4702,10 @@
         </p:spPr>
         <p:txBody>
           <a:bodyPr/>
-          <a:p/>
+          <a:lstStyle/>
+          <a:p>
+            <a:endParaRPr/>
+          </a:p>
         </p:txBody>
       </p:sp>
       <p:graphicFrame>
@@ -3858,7 +4773,7 @@
                         </a:rPr>
                         <a:t>Method</a:t>
                       </a:r>
-                      <a:endParaRPr lang="en-US" sz="2000" dirty="0" b="1">
+                      <a:endParaRPr lang="en-US" sz="2000" b="1" dirty="0">
                         <a:latin typeface="Times New Roman"/>
                         <a:ea typeface="Times New Roman"/>
                         <a:cs typeface="Times New Roman"/>
@@ -3926,7 +4841,7 @@
                         </a:rPr>
                         <a:t>Endpoint</a:t>
                       </a:r>
-                      <a:endParaRPr lang="en-US" sz="2000" dirty="0" b="1">
+                      <a:endParaRPr lang="en-US" sz="2000" b="1" dirty="0">
                         <a:latin typeface="Times New Roman"/>
                         <a:ea typeface="Times New Roman"/>
                         <a:cs typeface="Times New Roman"/>
@@ -3994,7 +4909,7 @@
                         </a:rPr>
                         <a:t>Description</a:t>
                       </a:r>
-                      <a:endParaRPr lang="en-US" sz="2000" dirty="0" b="1">
+                      <a:endParaRPr lang="en-US" sz="2000" b="1" dirty="0">
                         <a:latin typeface="Times New Roman"/>
                         <a:ea typeface="Times New Roman"/>
                         <a:cs typeface="Times New Roman"/>
@@ -4678,7 +5593,7 @@
                 </a:tc>
                 <a:extLst>
                   <a:ext uri="{0D108BD9-81ED-4DB2-BD59-A6C34878D82A}">
-                    <a16:rowId xmlns:a16="http://schemas.microsoft.com/office/drawing/2014/main" val="10001"/>
+                    <a16:rowId xmlns:a16="http://schemas.microsoft.com/office/drawing/2014/main" val="33249153"/>
                   </a:ext>
                 </a:extLst>
               </a:tr>
@@ -4889,7 +5804,7 @@
                 </a:tc>
                 <a:extLst>
                   <a:ext uri="{0D108BD9-81ED-4DB2-BD59-A6C34878D82A}">
-                    <a16:rowId xmlns:a16="http://schemas.microsoft.com/office/drawing/2014/main" val="10002"/>
+                    <a16:rowId xmlns:a16="http://schemas.microsoft.com/office/drawing/2014/main" val="2859857452"/>
                   </a:ext>
                 </a:extLst>
               </a:tr>
@@ -5100,7 +6015,7 @@
                 </a:tc>
                 <a:extLst>
                   <a:ext uri="{0D108BD9-81ED-4DB2-BD59-A6C34878D82A}">
-                    <a16:rowId xmlns:a16="http://schemas.microsoft.com/office/drawing/2014/main" val="10001"/>
+                    <a16:rowId xmlns:a16="http://schemas.microsoft.com/office/drawing/2014/main" val="2233264584"/>
                   </a:ext>
                 </a:extLst>
               </a:tr>
@@ -5311,7 +6226,7 @@
                 </a:tc>
                 <a:extLst>
                   <a:ext uri="{0D108BD9-81ED-4DB2-BD59-A6C34878D82A}">
-                    <a16:rowId xmlns:a16="http://schemas.microsoft.com/office/drawing/2014/main" val="10002"/>
+                    <a16:rowId xmlns:a16="http://schemas.microsoft.com/office/drawing/2014/main" val="3991298979"/>
                   </a:ext>
                 </a:extLst>
               </a:tr>
@@ -5522,7 +6437,7 @@
                 </a:tc>
                 <a:extLst>
                   <a:ext uri="{0D108BD9-81ED-4DB2-BD59-A6C34878D82A}">
-                    <a16:rowId xmlns:a16="http://schemas.microsoft.com/office/drawing/2014/main" val="10001"/>
+                    <a16:rowId xmlns:a16="http://schemas.microsoft.com/office/drawing/2014/main" val="1683918120"/>
                   </a:ext>
                 </a:extLst>
               </a:tr>
@@ -5733,7 +6648,7 @@
                 </a:tc>
                 <a:extLst>
                   <a:ext uri="{0D108BD9-81ED-4DB2-BD59-A6C34878D82A}">
-                    <a16:rowId xmlns:a16="http://schemas.microsoft.com/office/drawing/2014/main" val="10002"/>
+                    <a16:rowId xmlns:a16="http://schemas.microsoft.com/office/drawing/2014/main" val="2097609021"/>
                   </a:ext>
                 </a:extLst>
               </a:tr>
@@ -5944,7 +6859,7 @@
                 </a:tc>
                 <a:extLst>
                   <a:ext uri="{0D108BD9-81ED-4DB2-BD59-A6C34878D82A}">
-                    <a16:rowId xmlns:a16="http://schemas.microsoft.com/office/drawing/2014/main" val="10001"/>
+                    <a16:rowId xmlns:a16="http://schemas.microsoft.com/office/drawing/2014/main" val="2622948568"/>
                   </a:ext>
                 </a:extLst>
               </a:tr>
@@ -6046,7 +6961,7 @@
 </p:sld>
 </file>
 
-<file path=ppt/slides/slide13.xml><?xml version="1.0" encoding="utf-8"?>
+<file path=ppt/slides/slide14.xml><?xml version="1.0" encoding="utf-8"?>
 <p:sld xmlns:a="http://schemas.openxmlformats.org/drawingml/2006/main" xmlns:r="http://schemas.openxmlformats.org/officeDocument/2006/relationships" xmlns:p="http://schemas.openxmlformats.org/presentationml/2006/main">
   <p:cSld name="Slide 14">
     <p:bg>
@@ -6092,7 +7007,10 @@
         </p:spPr>
         <p:txBody>
           <a:bodyPr/>
-          <a:p/>
+          <a:lstStyle/>
+          <a:p>
+            <a:endParaRPr/>
+          </a:p>
         </p:txBody>
       </p:sp>
       <p:sp>
@@ -6130,7 +7048,7 @@
               </a:rPr>
               <a:t>12</a:t>
             </a:r>
-            <a:endParaRPr lang="en-US" sz="1800" dirty="0" b="1">
+            <a:endParaRPr lang="en-US" sz="1800" b="1" dirty="0">
               <a:latin typeface="Times New Roman"/>
               <a:ea typeface="Times New Roman"/>
               <a:cs typeface="Times New Roman"/>
@@ -6216,7 +7134,7 @@
               </a:rPr>
               <a:t>Module-wise Implementation Status</a:t>
             </a:r>
-            <a:endParaRPr lang="en-US" sz="2800" dirty="0" b="1">
+            <a:endParaRPr lang="en-US" sz="2800" b="1" dirty="0">
               <a:latin typeface="Times New Roman"/>
               <a:ea typeface="Times New Roman"/>
               <a:cs typeface="Times New Roman"/>
@@ -6248,7 +7166,10 @@
         </p:spPr>
         <p:txBody>
           <a:bodyPr/>
-          <a:p/>
+          <a:lstStyle/>
+          <a:p>
+            <a:endParaRPr/>
+          </a:p>
         </p:txBody>
       </p:sp>
       <p:sp>
@@ -6322,7 +7243,10 @@
         </p:spPr>
         <p:txBody>
           <a:bodyPr/>
-          <a:p/>
+          <a:lstStyle/>
+          <a:p>
+            <a:endParaRPr/>
+          </a:p>
         </p:txBody>
       </p:sp>
       <p:sp>
@@ -6348,7 +7272,10 @@
         </p:spPr>
         <p:txBody>
           <a:bodyPr/>
-          <a:p/>
+          <a:lstStyle/>
+          <a:p>
+            <a:endParaRPr/>
+          </a:p>
         </p:txBody>
       </p:sp>
       <p:sp>
@@ -6386,7 +7313,7 @@
               </a:rPr>
               <a:t>100%</a:t>
             </a:r>
-            <a:endParaRPr lang="en-US" sz="1800" dirty="0" b="1">
+            <a:endParaRPr lang="en-US" sz="1800" b="1" dirty="0">
               <a:latin typeface="Times New Roman"/>
               <a:ea typeface="Times New Roman"/>
               <a:cs typeface="Times New Roman"/>
@@ -6465,7 +7392,10 @@
         </p:spPr>
         <p:txBody>
           <a:bodyPr/>
-          <a:p/>
+          <a:lstStyle/>
+          <a:p>
+            <a:endParaRPr/>
+          </a:p>
         </p:txBody>
       </p:sp>
       <p:sp>
@@ -6491,7 +7421,10 @@
         </p:spPr>
         <p:txBody>
           <a:bodyPr/>
-          <a:p/>
+          <a:lstStyle/>
+          <a:p>
+            <a:endParaRPr/>
+          </a:p>
         </p:txBody>
       </p:sp>
       <p:sp>
@@ -6529,7 +7462,7 @@
               </a:rPr>
               <a:t>89%</a:t>
             </a:r>
-            <a:endParaRPr lang="en-US" sz="1800" dirty="0" b="1">
+            <a:endParaRPr lang="en-US" sz="1800" b="1" dirty="0">
               <a:latin typeface="Times New Roman"/>
               <a:ea typeface="Times New Roman"/>
               <a:cs typeface="Times New Roman"/>
@@ -6608,7 +7541,10 @@
         </p:spPr>
         <p:txBody>
           <a:bodyPr/>
-          <a:p/>
+          <a:lstStyle/>
+          <a:p>
+            <a:endParaRPr/>
+          </a:p>
         </p:txBody>
       </p:sp>
       <p:sp>
@@ -6634,7 +7570,10 @@
         </p:spPr>
         <p:txBody>
           <a:bodyPr/>
-          <a:p/>
+          <a:lstStyle/>
+          <a:p>
+            <a:endParaRPr/>
+          </a:p>
         </p:txBody>
       </p:sp>
       <p:sp>
@@ -6672,7 +7611,7 @@
               </a:rPr>
               <a:t>90%</a:t>
             </a:r>
-            <a:endParaRPr lang="en-US" sz="1800" dirty="0" b="1">
+            <a:endParaRPr lang="en-US" sz="1800" b="1" dirty="0">
               <a:latin typeface="Times New Roman"/>
               <a:ea typeface="Times New Roman"/>
               <a:cs typeface="Times New Roman"/>
@@ -6751,7 +7690,10 @@
         </p:spPr>
         <p:txBody>
           <a:bodyPr/>
-          <a:p/>
+          <a:lstStyle/>
+          <a:p>
+            <a:endParaRPr/>
+          </a:p>
         </p:txBody>
       </p:sp>
       <p:sp>
@@ -6777,7 +7719,10 @@
         </p:spPr>
         <p:txBody>
           <a:bodyPr/>
-          <a:p/>
+          <a:lstStyle/>
+          <a:p>
+            <a:endParaRPr/>
+          </a:p>
         </p:txBody>
       </p:sp>
       <p:sp>
@@ -6815,7 +7760,7 @@
               </a:rPr>
               <a:t>90%</a:t>
             </a:r>
-            <a:endParaRPr lang="en-US" sz="1800" dirty="0" b="1">
+            <a:endParaRPr lang="en-US" sz="1800" b="1" dirty="0">
               <a:latin typeface="Times New Roman"/>
               <a:ea typeface="Times New Roman"/>
               <a:cs typeface="Times New Roman"/>
@@ -6894,7 +7839,10 @@
         </p:spPr>
         <p:txBody>
           <a:bodyPr/>
-          <a:p/>
+          <a:lstStyle/>
+          <a:p>
+            <a:endParaRPr/>
+          </a:p>
         </p:txBody>
       </p:sp>
       <p:sp>
@@ -6920,7 +7868,10 @@
         </p:spPr>
         <p:txBody>
           <a:bodyPr/>
-          <a:p/>
+          <a:lstStyle/>
+          <a:p>
+            <a:endParaRPr/>
+          </a:p>
         </p:txBody>
       </p:sp>
       <p:sp>
@@ -6958,7 +7909,7 @@
               </a:rPr>
               <a:t>100%</a:t>
             </a:r>
-            <a:endParaRPr lang="en-US" sz="1800" dirty="0" b="1">
+            <a:endParaRPr lang="en-US" sz="1800" b="1" dirty="0">
               <a:latin typeface="Times New Roman"/>
               <a:ea typeface="Times New Roman"/>
               <a:cs typeface="Times New Roman"/>
@@ -6999,7 +7950,7 @@
                 <a:ea typeface="Times New Roman"/>
                 <a:cs typeface="Times New Roman"/>
               </a:rPr>
-              <a:t>Notifications (7/7)</a:t>
+              <a:t>Notifications (5/7)</a:t>
             </a:r>
             <a:endParaRPr lang="en-US" sz="1800" dirty="0">
               <a:latin typeface="Times New Roman"/>
@@ -7037,7 +7988,10 @@
         </p:spPr>
         <p:txBody>
           <a:bodyPr/>
-          <a:p/>
+          <a:lstStyle/>
+          <a:p>
+            <a:endParaRPr/>
+          </a:p>
         </p:txBody>
       </p:sp>
       <p:sp>
@@ -7048,8 +8002,8 @@
         </p:nvSpPr>
         <p:spPr>
           <a:xfrm>
-            <a:off x="4572000" y="4992624"/>
-            <a:ext cx="5486400" cy="274320"/>
+            <a:off x="4572000" y="5010912"/>
+            <a:ext cx="4516016" cy="256031"/>
           </a:xfrm>
           <a:prstGeom prst="roundRect">
             <a:avLst>
@@ -7063,7 +8017,10 @@
         </p:spPr>
         <p:txBody>
           <a:bodyPr/>
-          <a:p/>
+          <a:lstStyle/>
+          <a:p>
+            <a:endParaRPr/>
+          </a:p>
         </p:txBody>
       </p:sp>
       <p:sp>
@@ -7099,9 +8056,9 @@
                 <a:ea typeface="Times New Roman"/>
                 <a:cs typeface="Times New Roman"/>
               </a:rPr>
-              <a:t>100%</a:t>
-            </a:r>
-            <a:endParaRPr lang="en-US" sz="1800" dirty="0" b="1">
+              <a:t>70%</a:t>
+            </a:r>
+            <a:endParaRPr lang="en-US" sz="1800" b="1" dirty="0">
               <a:latin typeface="Times New Roman"/>
               <a:ea typeface="Times New Roman"/>
               <a:cs typeface="Times New Roman"/>
@@ -7203,7 +8160,7 @@
 </p:sld>
 </file>
 
-<file path=ppt/slides/slide14.xml><?xml version="1.0" encoding="utf-8"?>
+<file path=ppt/slides/slide15.xml><?xml version="1.0" encoding="utf-8"?>
 <p:sld xmlns:a="http://schemas.openxmlformats.org/drawingml/2006/main" xmlns:r="http://schemas.openxmlformats.org/officeDocument/2006/relationships" xmlns:p="http://schemas.openxmlformats.org/presentationml/2006/main">
   <p:cSld name="Slide 15">
     <p:bg>
@@ -7249,7 +8206,10 @@
         </p:spPr>
         <p:txBody>
           <a:bodyPr/>
-          <a:p/>
+          <a:lstStyle/>
+          <a:p>
+            <a:endParaRPr/>
+          </a:p>
         </p:txBody>
       </p:sp>
       <p:sp>
@@ -7287,7 +8247,7 @@
               </a:rPr>
               <a:t>13</a:t>
             </a:r>
-            <a:endParaRPr lang="en-US" sz="1800" dirty="0" b="1">
+            <a:endParaRPr lang="en-US" sz="1800" b="1" dirty="0">
               <a:latin typeface="Times New Roman"/>
               <a:ea typeface="Times New Roman"/>
               <a:cs typeface="Times New Roman"/>
@@ -7373,7 +8333,7 @@
               </a:rPr>
               <a:t>Screenshots</a:t>
             </a:r>
-            <a:endParaRPr lang="en-US" sz="2800" dirty="0" b="1">
+            <a:endParaRPr lang="en-US" sz="2800" b="1" dirty="0">
               <a:latin typeface="Times New Roman"/>
               <a:ea typeface="Times New Roman"/>
               <a:cs typeface="Times New Roman"/>
@@ -7405,7 +8365,10 @@
         </p:spPr>
         <p:txBody>
           <a:bodyPr/>
-          <a:p/>
+          <a:lstStyle/>
+          <a:p>
+            <a:endParaRPr/>
+          </a:p>
         </p:txBody>
       </p:sp>
       <p:sp>
@@ -7436,7 +8399,10 @@
         </p:spPr>
         <p:txBody>
           <a:bodyPr/>
-          <a:p/>
+          <a:lstStyle/>
+          <a:p>
+            <a:endParaRPr/>
+          </a:p>
         </p:txBody>
       </p:sp>
       <p:sp>
@@ -7474,7 +8440,7 @@
               </a:rPr>
               <a:t>Login page</a:t>
             </a:r>
-            <a:endParaRPr lang="en-US" sz="1800" dirty="0" i="0">
+            <a:endParaRPr lang="en-US" sz="1800" i="0" dirty="0">
               <a:latin typeface="Times New Roman"/>
               <a:ea typeface="Times New Roman"/>
               <a:cs typeface="Times New Roman"/>
@@ -7510,7 +8476,10 @@
         </p:spPr>
         <p:txBody>
           <a:bodyPr/>
-          <a:p/>
+          <a:lstStyle/>
+          <a:p>
+            <a:endParaRPr/>
+          </a:p>
         </p:txBody>
       </p:sp>
       <p:sp>
@@ -7548,7 +8517,7 @@
               </a:rPr>
               <a:t>User dashboard</a:t>
             </a:r>
-            <a:endParaRPr lang="en-US" sz="1800" dirty="0" i="0">
+            <a:endParaRPr lang="en-US" sz="1800" i="0" dirty="0">
               <a:latin typeface="Times New Roman"/>
               <a:ea typeface="Times New Roman"/>
               <a:cs typeface="Times New Roman"/>
@@ -7584,7 +8553,10 @@
         </p:spPr>
         <p:txBody>
           <a:bodyPr/>
-          <a:p/>
+          <a:lstStyle/>
+          <a:p>
+            <a:endParaRPr/>
+          </a:p>
         </p:txBody>
       </p:sp>
       <p:sp>
@@ -7622,7 +8594,7 @@
               </a:rPr>
               <a:t>Credibility report</a:t>
             </a:r>
-            <a:endParaRPr lang="en-US" sz="1800" dirty="0" i="0">
+            <a:endParaRPr lang="en-US" sz="1800" i="0" dirty="0">
               <a:latin typeface="Times New Roman"/>
               <a:ea typeface="Times New Roman"/>
               <a:cs typeface="Times New Roman"/>
@@ -7658,7 +8630,10 @@
         </p:spPr>
         <p:txBody>
           <a:bodyPr/>
-          <a:p/>
+          <a:lstStyle/>
+          <a:p>
+            <a:endParaRPr/>
+          </a:p>
         </p:txBody>
       </p:sp>
       <p:sp>
@@ -7696,7 +8671,7 @@
               </a:rPr>
               <a:t>Admin dashboard</a:t>
             </a:r>
-            <a:endParaRPr lang="en-US" sz="1800" dirty="0" i="0">
+            <a:endParaRPr lang="en-US" sz="1800" i="0" dirty="0">
               <a:latin typeface="Times New Roman"/>
               <a:ea typeface="Times New Roman"/>
               <a:cs typeface="Times New Roman"/>
@@ -7894,7 +8869,7 @@
 </p:sld>
 </file>
 
-<file path=ppt/slides/slide15.xml><?xml version="1.0" encoding="utf-8"?>
+<file path=ppt/slides/slide16.xml><?xml version="1.0" encoding="utf-8"?>
 <p:sld xmlns:a="http://schemas.openxmlformats.org/drawingml/2006/main" xmlns:r="http://schemas.openxmlformats.org/officeDocument/2006/relationships" xmlns:p="http://schemas.openxmlformats.org/presentationml/2006/main">
   <p:cSld name="Slide 17">
     <p:bg>
@@ -7940,7 +8915,10 @@
         </p:spPr>
         <p:txBody>
           <a:bodyPr/>
-          <a:p/>
+          <a:lstStyle/>
+          <a:p>
+            <a:endParaRPr/>
+          </a:p>
         </p:txBody>
       </p:sp>
       <p:sp>
@@ -7978,7 +8956,7 @@
               </a:rPr>
               <a:t>14</a:t>
             </a:r>
-            <a:endParaRPr lang="en-US" sz="1800" dirty="0" b="1">
+            <a:endParaRPr lang="en-US" sz="1800" b="1" dirty="0">
               <a:latin typeface="Times New Roman"/>
               <a:ea typeface="Times New Roman"/>
               <a:cs typeface="Times New Roman"/>
@@ -8064,7 +9042,7 @@
               </a:rPr>
               <a:t>Challenges Faced &amp; Solutions</a:t>
             </a:r>
-            <a:endParaRPr lang="en-US" sz="2800" dirty="0" b="1">
+            <a:endParaRPr lang="en-US" sz="2800" b="1" dirty="0">
               <a:latin typeface="Times New Roman"/>
               <a:ea typeface="Times New Roman"/>
               <a:cs typeface="Times New Roman"/>
@@ -8096,7 +9074,10 @@
         </p:spPr>
         <p:txBody>
           <a:bodyPr/>
-          <a:p/>
+          <a:lstStyle/>
+          <a:p>
+            <a:endParaRPr/>
+          </a:p>
         </p:txBody>
       </p:sp>
       <p:graphicFrame>
@@ -8115,7 +9096,7 @@
         </p:nvGraphicFramePr>
         <p:xfrm>
           <a:off x="1097280" y="1691640"/>
-          <a:ext cx="9966960" cy="3200400"/>
+          <a:ext cx="9966960" cy="3566160"/>
         </p:xfrm>
         <a:graphic>
           <a:graphicData uri="http://schemas.openxmlformats.org/drawingml/2006/table">
@@ -8157,7 +9138,7 @@
                         </a:rPr>
                         <a:t>Challenge</a:t>
                       </a:r>
-                      <a:endParaRPr lang="en-US" sz="2000" dirty="0" b="1">
+                      <a:endParaRPr lang="en-US" sz="2000" b="1" dirty="0">
                         <a:latin typeface="Times New Roman"/>
                         <a:ea typeface="Times New Roman"/>
                         <a:cs typeface="Times New Roman"/>
@@ -8225,7 +9206,7 @@
                         </a:rPr>
                         <a:t>Solution Adopted</a:t>
                       </a:r>
-                      <a:endParaRPr lang="en-US" sz="2000" dirty="0" b="1">
+                      <a:endParaRPr lang="en-US" sz="2000" b="1" dirty="0">
                         <a:latin typeface="Times New Roman"/>
                         <a:ea typeface="Times New Roman"/>
                         <a:cs typeface="Times New Roman"/>
@@ -8705,7 +9686,7 @@
                 </a:tc>
                 <a:extLst>
                   <a:ext uri="{0D108BD9-81ED-4DB2-BD59-A6C34878D82A}">
-                    <a16:rowId xmlns:a16="http://schemas.microsoft.com/office/drawing/2014/main" val="10001"/>
+                    <a16:rowId xmlns:a16="http://schemas.microsoft.com/office/drawing/2014/main" val="1049312462"/>
                   </a:ext>
                 </a:extLst>
               </a:tr>
@@ -8848,7 +9829,7 @@
                 </a:tc>
                 <a:extLst>
                   <a:ext uri="{0D108BD9-81ED-4DB2-BD59-A6C34878D82A}">
-                    <a16:rowId xmlns:a16="http://schemas.microsoft.com/office/drawing/2014/main" val="10002"/>
+                    <a16:rowId xmlns:a16="http://schemas.microsoft.com/office/drawing/2014/main" val="1601579138"/>
                   </a:ext>
                 </a:extLst>
               </a:tr>
@@ -8991,7 +9972,7 @@
                 </a:tc>
                 <a:extLst>
                   <a:ext uri="{0D108BD9-81ED-4DB2-BD59-A6C34878D82A}">
-                    <a16:rowId xmlns:a16="http://schemas.microsoft.com/office/drawing/2014/main" val="10001"/>
+                    <a16:rowId xmlns:a16="http://schemas.microsoft.com/office/drawing/2014/main" val="472454647"/>
                   </a:ext>
                 </a:extLst>
               </a:tr>
@@ -9134,7 +10115,7 @@
                 </a:tc>
                 <a:extLst>
                   <a:ext uri="{0D108BD9-81ED-4DB2-BD59-A6C34878D82A}">
-                    <a16:rowId xmlns:a16="http://schemas.microsoft.com/office/drawing/2014/main" val="10002"/>
+                    <a16:rowId xmlns:a16="http://schemas.microsoft.com/office/drawing/2014/main" val="4036735405"/>
                   </a:ext>
                 </a:extLst>
               </a:tr>
@@ -9236,7 +10217,7 @@
 </p:sld>
 </file>
 
-<file path=ppt/slides/slide16.xml><?xml version="1.0" encoding="utf-8"?>
+<file path=ppt/slides/slide17.xml><?xml version="1.0" encoding="utf-8"?>
 <p:sld xmlns:a="http://schemas.openxmlformats.org/drawingml/2006/main" xmlns:r="http://schemas.openxmlformats.org/officeDocument/2006/relationships" xmlns:p="http://schemas.openxmlformats.org/presentationml/2006/main">
   <p:cSld name="Slide 18">
     <p:bg>
@@ -9282,7 +10263,10 @@
         </p:spPr>
         <p:txBody>
           <a:bodyPr/>
-          <a:p/>
+          <a:lstStyle/>
+          <a:p>
+            <a:endParaRPr/>
+          </a:p>
         </p:txBody>
       </p:sp>
       <p:sp>
@@ -9320,7 +10304,7 @@
               </a:rPr>
               <a:t>15</a:t>
             </a:r>
-            <a:endParaRPr lang="en-US" sz="1800" dirty="0" b="1">
+            <a:endParaRPr lang="en-US" sz="1800" b="1" dirty="0">
               <a:latin typeface="Times New Roman"/>
               <a:ea typeface="Times New Roman"/>
               <a:cs typeface="Times New Roman"/>
@@ -9406,7 +10390,7 @@
               </a:rPr>
               <a:t>Remaining Work &amp; Plan</a:t>
             </a:r>
-            <a:endParaRPr lang="en-US" sz="2800" dirty="0" b="1">
+            <a:endParaRPr lang="en-US" sz="2800" b="1" dirty="0">
               <a:latin typeface="Times New Roman"/>
               <a:ea typeface="Times New Roman"/>
               <a:cs typeface="Times New Roman"/>
@@ -9438,7 +10422,10 @@
         </p:spPr>
         <p:txBody>
           <a:bodyPr/>
-          <a:p/>
+          <a:lstStyle/>
+          <a:p>
+            <a:endParaRPr/>
+          </a:p>
         </p:txBody>
       </p:sp>
       <p:sp>
@@ -9449,7 +10436,7 @@
         </p:nvSpPr>
         <p:spPr>
           <a:xfrm>
-            <a:off x="1097280" y="1691640"/>
+            <a:off x="1097280" y="731520"/>
             <a:ext cx="9875520" cy="4206240"/>
           </a:xfrm>
           <a:prstGeom prst="rect">
@@ -9707,7 +10694,7 @@
 </p:sld>
 </file>
 
-<file path=ppt/slides/slide17.xml><?xml version="1.0" encoding="utf-8"?>
+<file path=ppt/slides/slide18.xml><?xml version="1.0" encoding="utf-8"?>
 <p:sld xmlns:a="http://schemas.openxmlformats.org/drawingml/2006/main" xmlns:r="http://schemas.openxmlformats.org/officeDocument/2006/relationships" xmlns:p="http://schemas.openxmlformats.org/presentationml/2006/main">
   <p:cSld name="Slide 20">
     <p:bg>
@@ -9753,7 +10740,10 @@
         </p:spPr>
         <p:txBody>
           <a:bodyPr/>
-          <a:p/>
+          <a:lstStyle/>
+          <a:p>
+            <a:endParaRPr/>
+          </a:p>
         </p:txBody>
       </p:sp>
       <p:sp>
@@ -9791,7 +10781,7 @@
               </a:rPr>
               <a:t>16</a:t>
             </a:r>
-            <a:endParaRPr lang="en-US" sz="1800" dirty="0" b="1">
+            <a:endParaRPr lang="en-US" sz="1800" b="1" dirty="0">
               <a:latin typeface="Times New Roman"/>
               <a:ea typeface="Times New Roman"/>
               <a:cs typeface="Times New Roman"/>
@@ -9877,7 +10867,7 @@
               </a:rPr>
               <a:t>References</a:t>
             </a:r>
-            <a:endParaRPr lang="en-US" sz="2800" dirty="0" b="1">
+            <a:endParaRPr lang="en-US" sz="2800" b="1" dirty="0">
               <a:latin typeface="Times New Roman"/>
               <a:ea typeface="Times New Roman"/>
               <a:cs typeface="Times New Roman"/>
@@ -9909,7 +10899,10 @@
         </p:spPr>
         <p:txBody>
           <a:bodyPr/>
-          <a:p/>
+          <a:lstStyle/>
+          <a:p>
+            <a:endParaRPr/>
+          </a:p>
         </p:txBody>
       </p:sp>
       <p:graphicFrame>
@@ -9928,7 +10921,7 @@
         </p:nvGraphicFramePr>
         <p:xfrm>
           <a:off x="1097280" y="1691640"/>
-          <a:ext cx="9966960" cy="3200400"/>
+          <a:ext cx="9966960" cy="3566160"/>
         </p:xfrm>
         <a:graphic>
           <a:graphicData uri="http://schemas.openxmlformats.org/drawingml/2006/table">
@@ -9970,7 +10963,7 @@
                         </a:rPr>
                         <a:t>#</a:t>
                       </a:r>
-                      <a:endParaRPr lang="en-US" sz="2000" dirty="0" b="1">
+                      <a:endParaRPr lang="en-US" sz="2000" b="1" dirty="0">
                         <a:latin typeface="Times New Roman"/>
                         <a:ea typeface="Times New Roman"/>
                         <a:cs typeface="Times New Roman"/>
@@ -10038,7 +11031,7 @@
                         </a:rPr>
                         <a:t>Reference</a:t>
                       </a:r>
-                      <a:endParaRPr lang="en-US" sz="2000" dirty="0" b="1">
+                      <a:endParaRPr lang="en-US" sz="2000" b="1" dirty="0">
                         <a:latin typeface="Times New Roman"/>
                         <a:ea typeface="Times New Roman"/>
                         <a:cs typeface="Times New Roman"/>
@@ -10518,7 +11511,7 @@
                 </a:tc>
                 <a:extLst>
                   <a:ext uri="{0D108BD9-81ED-4DB2-BD59-A6C34878D82A}">
-                    <a16:rowId xmlns:a16="http://schemas.microsoft.com/office/drawing/2014/main" val="10001"/>
+                    <a16:rowId xmlns:a16="http://schemas.microsoft.com/office/drawing/2014/main" val="1280389864"/>
                   </a:ext>
                 </a:extLst>
               </a:tr>
@@ -10661,7 +11654,7 @@
                 </a:tc>
                 <a:extLst>
                   <a:ext uri="{0D108BD9-81ED-4DB2-BD59-A6C34878D82A}">
-                    <a16:rowId xmlns:a16="http://schemas.microsoft.com/office/drawing/2014/main" val="10002"/>
+                    <a16:rowId xmlns:a16="http://schemas.microsoft.com/office/drawing/2014/main" val="1708523632"/>
                   </a:ext>
                 </a:extLst>
               </a:tr>
@@ -10804,7 +11797,7 @@
                 </a:tc>
                 <a:extLst>
                   <a:ext uri="{0D108BD9-81ED-4DB2-BD59-A6C34878D82A}">
-                    <a16:rowId xmlns:a16="http://schemas.microsoft.com/office/drawing/2014/main" val="10001"/>
+                    <a16:rowId xmlns:a16="http://schemas.microsoft.com/office/drawing/2014/main" val="324305099"/>
                   </a:ext>
                 </a:extLst>
               </a:tr>
@@ -10947,7 +11940,7 @@
                 </a:tc>
                 <a:extLst>
                   <a:ext uri="{0D108BD9-81ED-4DB2-BD59-A6C34878D82A}">
-                    <a16:rowId xmlns:a16="http://schemas.microsoft.com/office/drawing/2014/main" val="10002"/>
+                    <a16:rowId xmlns:a16="http://schemas.microsoft.com/office/drawing/2014/main" val="1282320833"/>
                   </a:ext>
                 </a:extLst>
               </a:tr>
@@ -11050,6 +12043,467 @@
 </file>
 
 <file path=ppt/slides/slide2.xml><?xml version="1.0" encoding="utf-8"?>
+<p:sld xmlns:a="http://schemas.openxmlformats.org/drawingml/2006/main" xmlns:r="http://schemas.openxmlformats.org/officeDocument/2006/relationships" xmlns:p="http://schemas.openxmlformats.org/presentationml/2006/main">
+  <p:cSld name="Slide 2">
+    <p:bg>
+      <p:bgPr>
+        <a:solidFill>
+          <a:srgbClr val="FFFFFF"/>
+        </a:solidFill>
+        <a:effectLst/>
+      </p:bgPr>
+    </p:bg>
+    <p:spTree>
+      <p:nvGrpSpPr>
+        <p:cNvPr id="1" name=""/>
+        <p:cNvGrpSpPr/>
+        <p:nvPr/>
+      </p:nvGrpSpPr>
+      <p:grpSpPr>
+        <a:xfrm>
+          <a:off x="0" y="0"/>
+          <a:ext cx="0" cy="0"/>
+          <a:chOff x="0" y="0"/>
+          <a:chExt cx="0" cy="0"/>
+        </a:xfrm>
+      </p:grpSpPr>
+      <p:sp>
+        <p:nvSpPr>
+          <p:cNvPr id="2" name="Text 0"/>
+          <p:cNvSpPr txBox="1"/>
+          <p:nvPr/>
+        </p:nvSpPr>
+        <p:spPr>
+          <a:xfrm>
+            <a:off x="1097280" y="457200"/>
+            <a:ext cx="5486400" cy="274320"/>
+          </a:xfrm>
+          <a:prstGeom prst="rect">
+            <a:avLst/>
+          </a:prstGeom>
+          <a:noFill/>
+          <a:ln/>
+        </p:spPr>
+        <p:txBody>
+          <a:bodyPr wrap="square" lIns="0" tIns="0" rIns="0" bIns="0" rtlCol="0" anchor="ctr"/>
+          <a:lstStyle/>
+          <a:p>
+            <a:pPr marL="0" indent="0">
+              <a:buNone/>
+            </a:pPr>
+            <a:r>
+              <a:rPr lang="en-US" sz="2000" b="1" kern="0" spc="200" dirty="0">
+                <a:solidFill>
+                  <a:srgbClr val="00A896"/>
+                </a:solidFill>
+                <a:latin typeface="Times New Roman"/>
+                <a:ea typeface="Times New Roman"/>
+                <a:cs typeface="Times New Roman"/>
+              </a:rPr>
+              <a:t>AGENDA</a:t>
+            </a:r>
+            <a:endParaRPr lang="en-US" sz="2000" dirty="0">
+              <a:latin typeface="Times New Roman"/>
+              <a:ea typeface="Times New Roman"/>
+              <a:cs typeface="Times New Roman"/>
+            </a:endParaRPr>
+          </a:p>
+        </p:txBody>
+      </p:sp>
+      <p:sp>
+        <p:nvSpPr>
+          <p:cNvPr id="3" name="Text 1"/>
+          <p:cNvSpPr txBox="1"/>
+          <p:nvPr/>
+        </p:nvSpPr>
+        <p:spPr>
+          <a:xfrm>
+            <a:off x="1097280" y="713232"/>
+            <a:ext cx="10058400" cy="548640"/>
+          </a:xfrm>
+          <a:prstGeom prst="rect">
+            <a:avLst/>
+          </a:prstGeom>
+          <a:noFill/>
+          <a:ln/>
+        </p:spPr>
+        <p:txBody>
+          <a:bodyPr wrap="square" lIns="0" tIns="0" rIns="0" bIns="0" rtlCol="0" anchor="ctr"/>
+          <a:lstStyle/>
+          <a:p>
+            <a:pPr marL="0" indent="0">
+              <a:buNone/>
+            </a:pPr>
+            <a:r>
+              <a:rPr lang="en-US" sz="2800" b="1" dirty="0">
+                <a:solidFill>
+                  <a:srgbClr val="1B2A2E"/>
+                </a:solidFill>
+                <a:latin typeface="Times New Roman"/>
+                <a:ea typeface="Times New Roman"/>
+                <a:cs typeface="Times New Roman"/>
+              </a:rPr>
+              <a:t>Scope of This Review</a:t>
+            </a:r>
+            <a:endParaRPr lang="en-US" sz="2800" b="1" dirty="0">
+              <a:latin typeface="Times New Roman"/>
+              <a:ea typeface="Times New Roman"/>
+              <a:cs typeface="Times New Roman"/>
+            </a:endParaRPr>
+          </a:p>
+        </p:txBody>
+      </p:sp>
+      <p:sp>
+        <p:nvSpPr>
+          <p:cNvPr id="4" name="Shape 2"/>
+          <p:cNvSpPr/>
+          <p:nvPr/>
+        </p:nvSpPr>
+        <p:spPr>
+          <a:xfrm>
+            <a:off x="1097280" y="1371600"/>
+            <a:ext cx="10607040" cy="0"/>
+          </a:xfrm>
+          <a:prstGeom prst="line">
+            <a:avLst/>
+          </a:prstGeom>
+          <a:noFill/>
+          <a:ln w="12700">
+            <a:solidFill>
+              <a:srgbClr val="D7E7E5"/>
+            </a:solidFill>
+            <a:prstDash val="solid"/>
+          </a:ln>
+        </p:spPr>
+        <p:txBody>
+          <a:bodyPr/>
+          <a:lstStyle/>
+          <a:p>
+            <a:endParaRPr/>
+          </a:p>
+        </p:txBody>
+      </p:sp>
+      <p:sp>
+        <p:nvSpPr>
+          <p:cNvPr id="8" name="Shape 6"/>
+          <p:cNvSpPr/>
+          <p:nvPr/>
+        </p:nvSpPr>
+        <p:spPr>
+          <a:xfrm>
+            <a:off x="998144" y="1700059"/>
+            <a:ext cx="5029200" cy="3713907"/>
+          </a:xfrm>
+          <a:prstGeom prst="roundRect">
+            <a:avLst>
+              <a:gd name="adj" fmla="val 1778"/>
+            </a:avLst>
+          </a:prstGeom>
+          <a:solidFill>
+            <a:srgbClr val="028090"/>
+          </a:solidFill>
+          <a:ln/>
+        </p:spPr>
+        <p:txBody>
+          <a:bodyPr/>
+          <a:lstStyle/>
+          <a:p>
+            <a:endParaRPr/>
+          </a:p>
+        </p:txBody>
+      </p:sp>
+      <p:sp>
+        <p:nvSpPr>
+          <p:cNvPr id="10" name="Text 8"/>
+          <p:cNvSpPr txBox="1"/>
+          <p:nvPr/>
+        </p:nvSpPr>
+        <p:spPr>
+          <a:xfrm>
+            <a:off x="1371600" y="2130643"/>
+            <a:ext cx="4572000" cy="2814903"/>
+          </a:xfrm>
+          <a:prstGeom prst="rect">
+            <a:avLst/>
+          </a:prstGeom>
+          <a:noFill/>
+          <a:ln/>
+        </p:spPr>
+        <p:txBody>
+          <a:bodyPr wrap="square" lIns="0" tIns="0" rIns="0" bIns="0" rtlCol="0" anchor="ctr"/>
+          <a:lstStyle/>
+          <a:p>
+            <a:pPr marL="342900" indent="-342900">
+              <a:spcAft>
+                <a:spcPts val="400"/>
+              </a:spcAft>
+              <a:buSzPct val="100000"/>
+              <a:buChar char="▪"/>
+            </a:pPr>
+            <a:r>
+              <a:rPr lang="en-US" sz="1800" dirty="0">
+                <a:solidFill>
+                  <a:srgbClr val="FFFFFF"/>
+                </a:solidFill>
+                <a:latin typeface="Times New Roman"/>
+                <a:ea typeface="Times New Roman"/>
+                <a:cs typeface="Times New Roman"/>
+              </a:rPr>
+              <a:t>Requirements (Functional &amp; NFR)</a:t>
+            </a:r>
+            <a:endParaRPr lang="en-US" sz="1800" dirty="0">
+              <a:latin typeface="Times New Roman"/>
+              <a:ea typeface="Times New Roman"/>
+              <a:cs typeface="Times New Roman"/>
+            </a:endParaRPr>
+          </a:p>
+          <a:p>
+            <a:pPr marL="342900" indent="-342900">
+              <a:spcAft>
+                <a:spcPts val="400"/>
+              </a:spcAft>
+              <a:buSzPct val="100000"/>
+              <a:buChar char="▪"/>
+            </a:pPr>
+            <a:r>
+              <a:rPr lang="en-US" sz="1800" dirty="0">
+                <a:solidFill>
+                  <a:srgbClr val="FFFFFF"/>
+                </a:solidFill>
+                <a:latin typeface="Times New Roman"/>
+                <a:ea typeface="Times New Roman"/>
+                <a:cs typeface="Times New Roman"/>
+              </a:rPr>
+              <a:t>Detailed System Architecture</a:t>
+            </a:r>
+            <a:endParaRPr lang="en-US" sz="1800" dirty="0">
+              <a:latin typeface="Times New Roman"/>
+              <a:ea typeface="Times New Roman"/>
+              <a:cs typeface="Times New Roman"/>
+            </a:endParaRPr>
+          </a:p>
+          <a:p>
+            <a:pPr marL="342900" indent="-342900">
+              <a:spcAft>
+                <a:spcPts val="400"/>
+              </a:spcAft>
+              <a:buSzPct val="100000"/>
+              <a:buChar char="▪"/>
+            </a:pPr>
+            <a:r>
+              <a:rPr lang="en-US" sz="1800" dirty="0">
+                <a:solidFill>
+                  <a:srgbClr val="FFFFFF"/>
+                </a:solidFill>
+                <a:latin typeface="Times New Roman"/>
+                <a:ea typeface="Times New Roman"/>
+                <a:cs typeface="Times New Roman"/>
+              </a:rPr>
+              <a:t>Use Case &amp; ER Diagrams</a:t>
+            </a:r>
+            <a:endParaRPr lang="en-US" sz="1800" dirty="0">
+              <a:latin typeface="Times New Roman"/>
+              <a:ea typeface="Times New Roman"/>
+              <a:cs typeface="Times New Roman"/>
+            </a:endParaRPr>
+          </a:p>
+          <a:p>
+            <a:pPr marL="342900" indent="-342900">
+              <a:spcAft>
+                <a:spcPts val="400"/>
+              </a:spcAft>
+              <a:buSzPct val="100000"/>
+              <a:buChar char="▪"/>
+            </a:pPr>
+            <a:r>
+              <a:rPr lang="en-US" sz="1800" dirty="0">
+                <a:solidFill>
+                  <a:srgbClr val="FFFFFF"/>
+                </a:solidFill>
+                <a:latin typeface="Times New Roman"/>
+                <a:ea typeface="Times New Roman"/>
+                <a:cs typeface="Times New Roman"/>
+              </a:rPr>
+              <a:t>Module Description &amp; Tech Stack</a:t>
+            </a:r>
+            <a:endParaRPr lang="en-US" sz="1800" dirty="0">
+              <a:latin typeface="Times New Roman"/>
+              <a:ea typeface="Times New Roman"/>
+              <a:cs typeface="Times New Roman"/>
+            </a:endParaRPr>
+          </a:p>
+          <a:p>
+            <a:pPr marL="342900" indent="-342900">
+              <a:spcAft>
+                <a:spcPts val="400"/>
+              </a:spcAft>
+              <a:buSzPct val="100000"/>
+              <a:buChar char="▪"/>
+            </a:pPr>
+            <a:r>
+              <a:rPr lang="en-US" sz="1800" dirty="0">
+                <a:solidFill>
+                  <a:srgbClr val="FFFFFF"/>
+                </a:solidFill>
+                <a:latin typeface="Times New Roman"/>
+                <a:ea typeface="Times New Roman"/>
+                <a:cs typeface="Times New Roman"/>
+              </a:rPr>
+              <a:t>UI Design, Frontend &amp; Backend Build</a:t>
+            </a:r>
+            <a:endParaRPr lang="en-US" sz="1800" dirty="0">
+              <a:latin typeface="Times New Roman"/>
+              <a:ea typeface="Times New Roman"/>
+              <a:cs typeface="Times New Roman"/>
+            </a:endParaRPr>
+          </a:p>
+          <a:p>
+            <a:pPr marL="342900" indent="-342900">
+              <a:spcAft>
+                <a:spcPts val="400"/>
+              </a:spcAft>
+              <a:buSzPct val="100000"/>
+              <a:buChar char="▪"/>
+            </a:pPr>
+            <a:r>
+              <a:rPr lang="en-US" sz="1800" dirty="0">
+                <a:solidFill>
+                  <a:srgbClr val="FFFFFF"/>
+                </a:solidFill>
+                <a:latin typeface="Times New Roman"/>
+                <a:ea typeface="Times New Roman"/>
+                <a:cs typeface="Times New Roman"/>
+              </a:rPr>
+              <a:t>Database &amp; API Integration</a:t>
+            </a:r>
+            <a:endParaRPr lang="en-US" sz="1800" dirty="0">
+              <a:latin typeface="Times New Roman"/>
+              <a:ea typeface="Times New Roman"/>
+              <a:cs typeface="Times New Roman"/>
+            </a:endParaRPr>
+          </a:p>
+          <a:p>
+            <a:pPr marL="342900" indent="-342900">
+              <a:spcAft>
+                <a:spcPts val="400"/>
+              </a:spcAft>
+              <a:buSzPct val="100000"/>
+              <a:buChar char="▪"/>
+            </a:pPr>
+            <a:r>
+              <a:rPr lang="en-US" sz="1800" dirty="0">
+                <a:solidFill>
+                  <a:srgbClr val="FFFFFF"/>
+                </a:solidFill>
+                <a:latin typeface="Times New Roman"/>
+                <a:ea typeface="Times New Roman"/>
+                <a:cs typeface="Times New Roman"/>
+              </a:rPr>
+              <a:t>Progress (94%), Screenshots &amp; Challenges</a:t>
+            </a:r>
+            <a:endParaRPr lang="en-US" sz="1800" dirty="0">
+              <a:latin typeface="Times New Roman"/>
+              <a:ea typeface="Times New Roman"/>
+              <a:cs typeface="Times New Roman"/>
+            </a:endParaRPr>
+          </a:p>
+        </p:txBody>
+      </p:sp>
+      <p:sp>
+        <p:nvSpPr>
+          <p:cNvPr id="11" name="Text 9"/>
+          <p:cNvSpPr txBox="1"/>
+          <p:nvPr/>
+        </p:nvSpPr>
+        <p:spPr>
+          <a:xfrm>
+            <a:off x="457200" y="6473952"/>
+            <a:ext cx="5486400" cy="274320"/>
+          </a:xfrm>
+          <a:prstGeom prst="rect">
+            <a:avLst/>
+          </a:prstGeom>
+          <a:noFill/>
+          <a:ln/>
+        </p:spPr>
+        <p:txBody>
+          <a:bodyPr wrap="square" lIns="0" tIns="0" rIns="0" bIns="0" rtlCol="0" anchor="ctr"/>
+          <a:lstStyle/>
+          <a:p>
+            <a:pPr marL="0" indent="0">
+              <a:buNone/>
+            </a:pPr>
+            <a:r>
+              <a:rPr lang="en-US" sz="1800" dirty="0">
+                <a:solidFill>
+                  <a:srgbClr val="7A8F8C"/>
+                </a:solidFill>
+                <a:latin typeface="Times New Roman"/>
+                <a:ea typeface="Times New Roman"/>
+                <a:cs typeface="Times New Roman"/>
+              </a:rPr>
+              <a:t>Agenda</a:t>
+            </a:r>
+            <a:endParaRPr lang="en-US" sz="1800" dirty="0">
+              <a:latin typeface="Times New Roman"/>
+              <a:ea typeface="Times New Roman"/>
+              <a:cs typeface="Times New Roman"/>
+            </a:endParaRPr>
+          </a:p>
+        </p:txBody>
+      </p:sp>
+      <p:sp>
+        <p:nvSpPr>
+          <p:cNvPr id="12" name="Text 10"/>
+          <p:cNvSpPr txBox="1"/>
+          <p:nvPr/>
+        </p:nvSpPr>
+        <p:spPr>
+          <a:xfrm>
+            <a:off x="6245352" y="6473952"/>
+            <a:ext cx="5486400" cy="274320"/>
+          </a:xfrm>
+          <a:prstGeom prst="rect">
+            <a:avLst/>
+          </a:prstGeom>
+          <a:noFill/>
+          <a:ln/>
+        </p:spPr>
+        <p:txBody>
+          <a:bodyPr wrap="square" lIns="0" tIns="0" rIns="0" bIns="0" rtlCol="0" anchor="ctr"/>
+          <a:lstStyle/>
+          <a:p>
+            <a:pPr marL="0" indent="0" algn="r">
+              <a:buNone/>
+            </a:pPr>
+            <a:r>
+              <a:rPr lang="en-US" sz="1800" dirty="0">
+                <a:solidFill>
+                  <a:srgbClr val="7A8F8C"/>
+                </a:solidFill>
+                <a:latin typeface="Times New Roman"/>
+                <a:ea typeface="Times New Roman"/>
+                <a:cs typeface="Times New Roman"/>
+              </a:rPr>
+              <a:t>Review 1  |  NewsGuard AI (MERN Stack)</a:t>
+            </a:r>
+            <a:endParaRPr lang="en-US" sz="1800" dirty="0">
+              <a:latin typeface="Times New Roman"/>
+              <a:ea typeface="Times New Roman"/>
+              <a:cs typeface="Times New Roman"/>
+            </a:endParaRPr>
+          </a:p>
+        </p:txBody>
+      </p:sp>
+    </p:spTree>
+  </p:cSld>
+  <p:clrMapOvr>
+    <a:masterClrMapping/>
+  </p:clrMapOvr>
+</p:sld>
+</file>
+
+<file path=ppt/slides/slide3.xml><?xml version="1.0" encoding="utf-8"?>
 <p:sld xmlns:a="http://schemas.openxmlformats.org/drawingml/2006/main" xmlns:r="http://schemas.openxmlformats.org/officeDocument/2006/relationships" xmlns:p="http://schemas.openxmlformats.org/presentationml/2006/main">
   <p:cSld name="Slide 3">
     <p:bg>
@@ -11095,7 +12549,10 @@
         </p:spPr>
         <p:txBody>
           <a:bodyPr/>
-          <a:p/>
+          <a:lstStyle/>
+          <a:p>
+            <a:endParaRPr/>
+          </a:p>
         </p:txBody>
       </p:sp>
       <p:sp>
@@ -11133,7 +12590,7 @@
               </a:rPr>
               <a:t>01</a:t>
             </a:r>
-            <a:endParaRPr lang="en-US" sz="1800" dirty="0" b="1">
+            <a:endParaRPr lang="en-US" sz="1800" b="1" dirty="0">
               <a:latin typeface="Times New Roman"/>
               <a:ea typeface="Times New Roman"/>
               <a:cs typeface="Times New Roman"/>
@@ -11219,7 +12676,7 @@
               </a:rPr>
               <a:t>Functional &amp; Non-Functional Requirements</a:t>
             </a:r>
-            <a:endParaRPr lang="en-US" sz="2800" dirty="0" b="1">
+            <a:endParaRPr lang="en-US" sz="2800" b="1" dirty="0">
               <a:latin typeface="Times New Roman"/>
               <a:ea typeface="Times New Roman"/>
               <a:cs typeface="Times New Roman"/>
@@ -11251,7 +12708,10 @@
         </p:spPr>
         <p:txBody>
           <a:bodyPr/>
-          <a:p/>
+          <a:lstStyle/>
+          <a:p>
+            <a:endParaRPr/>
+          </a:p>
         </p:txBody>
       </p:sp>
       <p:sp>
@@ -11282,7 +12742,10 @@
         </p:spPr>
         <p:txBody>
           <a:bodyPr/>
-          <a:p/>
+          <a:lstStyle/>
+          <a:p>
+            <a:endParaRPr/>
+          </a:p>
         </p:txBody>
       </p:sp>
       <p:sp>
@@ -11578,7 +13041,10 @@
         </p:spPr>
         <p:txBody>
           <a:bodyPr/>
-          <a:p/>
+          <a:lstStyle/>
+          <a:p>
+            <a:endParaRPr/>
+          </a:p>
         </p:txBody>
       </p:sp>
       <p:sp>
@@ -11915,7 +13381,7 @@
 </p:sld>
 </file>
 
-<file path=ppt/slides/slide3.xml><?xml version="1.0" encoding="utf-8"?>
+<file path=ppt/slides/slide4.xml><?xml version="1.0" encoding="utf-8"?>
 <p:sld xmlns:a="http://schemas.openxmlformats.org/drawingml/2006/main" xmlns:r="http://schemas.openxmlformats.org/officeDocument/2006/relationships" xmlns:p="http://schemas.openxmlformats.org/presentationml/2006/main">
   <p:cSld name="Slide 4">
     <p:bg>
@@ -11961,7 +13427,10 @@
         </p:spPr>
         <p:txBody>
           <a:bodyPr/>
-          <a:p/>
+          <a:lstStyle/>
+          <a:p>
+            <a:endParaRPr/>
+          </a:p>
         </p:txBody>
       </p:sp>
       <p:sp>
@@ -11999,7 +13468,7 @@
               </a:rPr>
               <a:t>02</a:t>
             </a:r>
-            <a:endParaRPr lang="en-US" sz="1800" dirty="0" b="1">
+            <a:endParaRPr lang="en-US" sz="1800" b="1" dirty="0">
               <a:latin typeface="Times New Roman"/>
               <a:ea typeface="Times New Roman"/>
               <a:cs typeface="Times New Roman"/>
@@ -12085,7 +13554,7 @@
               </a:rPr>
               <a:t>System Architecture (Detailed)</a:t>
             </a:r>
-            <a:endParaRPr lang="en-US" sz="2800" dirty="0" b="1">
+            <a:endParaRPr lang="en-US" sz="2800" b="1" dirty="0">
               <a:latin typeface="Times New Roman"/>
               <a:ea typeface="Times New Roman"/>
               <a:cs typeface="Times New Roman"/>
@@ -12117,7 +13586,10 @@
         </p:spPr>
         <p:txBody>
           <a:bodyPr/>
-          <a:p/>
+          <a:lstStyle/>
+          <a:p>
+            <a:endParaRPr/>
+          </a:p>
         </p:txBody>
       </p:sp>
       <p:sp>
@@ -12143,7 +13615,10 @@
         </p:spPr>
         <p:txBody>
           <a:bodyPr/>
-          <a:p/>
+          <a:lstStyle/>
+          <a:p>
+            <a:endParaRPr/>
+          </a:p>
         </p:txBody>
       </p:sp>
       <p:sp>
@@ -12361,7 +13836,10 @@
         </p:spPr>
         <p:txBody>
           <a:bodyPr/>
-          <a:p/>
+          <a:lstStyle/>
+          <a:p>
+            <a:endParaRPr/>
+          </a:p>
         </p:txBody>
       </p:sp>
       <p:sp>
@@ -12579,7 +14057,10 @@
         </p:spPr>
         <p:txBody>
           <a:bodyPr/>
-          <a:p/>
+          <a:lstStyle/>
+          <a:p>
+            <a:endParaRPr/>
+          </a:p>
         </p:txBody>
       </p:sp>
       <p:sp>
@@ -12802,7 +14283,10 @@
         </p:spPr>
         <p:txBody>
           <a:bodyPr/>
-          <a:p/>
+          <a:lstStyle/>
+          <a:p>
+            <a:endParaRPr/>
+          </a:p>
         </p:txBody>
       </p:sp>
       <p:sp>
@@ -12942,7 +14426,7 @@
 </p:sld>
 </file>
 
-<file path=ppt/slides/slide4.xml><?xml version="1.0" encoding="utf-8"?>
+<file path=ppt/slides/slide5.xml><?xml version="1.0" encoding="utf-8"?>
 <p:sld xmlns:a="http://schemas.openxmlformats.org/drawingml/2006/main" xmlns:r="http://schemas.openxmlformats.org/officeDocument/2006/relationships" xmlns:p="http://schemas.openxmlformats.org/presentationml/2006/main">
   <p:cSld name="Slide 5">
     <p:bg>
@@ -12988,7 +14472,10 @@
         </p:spPr>
         <p:txBody>
           <a:bodyPr/>
-          <a:p/>
+          <a:lstStyle/>
+          <a:p>
+            <a:endParaRPr/>
+          </a:p>
         </p:txBody>
       </p:sp>
       <p:sp>
@@ -13026,7 +14513,7 @@
               </a:rPr>
               <a:t>03</a:t>
             </a:r>
-            <a:endParaRPr lang="en-US" sz="1800" dirty="0" b="1">
+            <a:endParaRPr lang="en-US" sz="1800" b="1" dirty="0">
               <a:latin typeface="Times New Roman"/>
               <a:ea typeface="Times New Roman"/>
               <a:cs typeface="Times New Roman"/>
@@ -13112,7 +14599,7 @@
               </a:rPr>
               <a:t>Use Case Diagram</a:t>
             </a:r>
-            <a:endParaRPr lang="en-US" sz="2800" dirty="0" b="1">
+            <a:endParaRPr lang="en-US" sz="2800" b="1" dirty="0">
               <a:latin typeface="Times New Roman"/>
               <a:ea typeface="Times New Roman"/>
               <a:cs typeface="Times New Roman"/>
@@ -13144,7 +14631,10 @@
         </p:spPr>
         <p:txBody>
           <a:bodyPr/>
-          <a:p/>
+          <a:lstStyle/>
+          <a:p>
+            <a:endParaRPr/>
+          </a:p>
         </p:txBody>
       </p:sp>
       <p:sp>
@@ -13175,7 +14665,10 @@
         </p:spPr>
         <p:txBody>
           <a:bodyPr/>
-          <a:p/>
+          <a:lstStyle/>
+          <a:p>
+            <a:endParaRPr/>
+          </a:p>
         </p:txBody>
       </p:sp>
       <p:sp>
@@ -13206,7 +14699,10 @@
         </p:spPr>
         <p:txBody>
           <a:bodyPr/>
-          <a:p/>
+          <a:lstStyle/>
+          <a:p>
+            <a:endParaRPr/>
+          </a:p>
         </p:txBody>
       </p:sp>
       <p:sp>
@@ -13244,7 +14740,7 @@
               </a:rPr>
               <a:t>Actors &amp; Use Cases</a:t>
             </a:r>
-            <a:endParaRPr lang="en-US" sz="2000" dirty="0" b="1">
+            <a:endParaRPr lang="en-US" sz="2000" b="1" dirty="0">
               <a:latin typeface="Times New Roman"/>
               <a:ea typeface="Times New Roman"/>
               <a:cs typeface="Times New Roman"/>
@@ -13517,7 +15013,7 @@
 </p:sld>
 </file>
 
-<file path=ppt/slides/slide5.xml><?xml version="1.0" encoding="utf-8"?>
+<file path=ppt/slides/slide6.xml><?xml version="1.0" encoding="utf-8"?>
 <p:sld xmlns:a="http://schemas.openxmlformats.org/drawingml/2006/main" xmlns:r="http://schemas.openxmlformats.org/officeDocument/2006/relationships" xmlns:p="http://schemas.openxmlformats.org/presentationml/2006/main">
   <p:cSld name="Slide 6">
     <p:bg>
@@ -13563,7 +15059,10 @@
         </p:spPr>
         <p:txBody>
           <a:bodyPr/>
-          <a:p/>
+          <a:lstStyle/>
+          <a:p>
+            <a:endParaRPr/>
+          </a:p>
         </p:txBody>
       </p:sp>
       <p:sp>
@@ -13601,7 +15100,7 @@
               </a:rPr>
               <a:t>04</a:t>
             </a:r>
-            <a:endParaRPr lang="en-US" sz="1800" dirty="0" b="1">
+            <a:endParaRPr lang="en-US" sz="1800" b="1" dirty="0">
               <a:latin typeface="Times New Roman"/>
               <a:ea typeface="Times New Roman"/>
               <a:cs typeface="Times New Roman"/>
@@ -13687,7 +15186,7 @@
               </a:rPr>
               <a:t>ER Diagram / Database Design</a:t>
             </a:r>
-            <a:endParaRPr lang="en-US" sz="2800" dirty="0" b="1">
+            <a:endParaRPr lang="en-US" sz="2800" b="1" dirty="0">
               <a:latin typeface="Times New Roman"/>
               <a:ea typeface="Times New Roman"/>
               <a:cs typeface="Times New Roman"/>
@@ -13719,7 +15218,10 @@
         </p:spPr>
         <p:txBody>
           <a:bodyPr/>
-          <a:p/>
+          <a:lstStyle/>
+          <a:p>
+            <a:endParaRPr/>
+          </a:p>
         </p:txBody>
       </p:sp>
       <p:sp>
@@ -13750,7 +15252,10 @@
         </p:spPr>
         <p:txBody>
           <a:bodyPr/>
-          <a:p/>
+          <a:lstStyle/>
+          <a:p>
+            <a:endParaRPr/>
+          </a:p>
         </p:txBody>
       </p:sp>
       <p:sp>
@@ -13781,7 +15286,10 @@
         </p:spPr>
         <p:txBody>
           <a:bodyPr/>
-          <a:p/>
+          <a:lstStyle/>
+          <a:p>
+            <a:endParaRPr/>
+          </a:p>
         </p:txBody>
       </p:sp>
       <p:sp>
@@ -13819,7 +15327,7 @@
               </a:rPr>
               <a:t>Design Notes</a:t>
             </a:r>
-            <a:endParaRPr lang="en-US" sz="2000" dirty="0" b="1">
+            <a:endParaRPr lang="en-US" sz="2000" b="1" dirty="0">
               <a:latin typeface="Times New Roman"/>
               <a:ea typeface="Times New Roman"/>
               <a:cs typeface="Times New Roman"/>
@@ -14092,7 +15600,7 @@
 </p:sld>
 </file>
 
-<file path=ppt/slides/slide6.xml><?xml version="1.0" encoding="utf-8"?>
+<file path=ppt/slides/slide7.xml><?xml version="1.0" encoding="utf-8"?>
 <p:sld xmlns:a="http://schemas.openxmlformats.org/drawingml/2006/main" xmlns:r="http://schemas.openxmlformats.org/officeDocument/2006/relationships" xmlns:p="http://schemas.openxmlformats.org/presentationml/2006/main">
   <p:cSld name="Slide 7">
     <p:bg>
@@ -14138,7 +15646,10 @@
         </p:spPr>
         <p:txBody>
           <a:bodyPr/>
-          <a:p/>
+          <a:lstStyle/>
+          <a:p>
+            <a:endParaRPr/>
+          </a:p>
         </p:txBody>
       </p:sp>
       <p:sp>
@@ -14176,7 +15687,7 @@
               </a:rPr>
               <a:t>05</a:t>
             </a:r>
-            <a:endParaRPr lang="en-US" sz="1800" dirty="0" b="1">
+            <a:endParaRPr lang="en-US" sz="1800" b="1" dirty="0">
               <a:latin typeface="Times New Roman"/>
               <a:ea typeface="Times New Roman"/>
               <a:cs typeface="Times New Roman"/>
@@ -14262,7 +15773,7 @@
               </a:rPr>
               <a:t>Module Description</a:t>
             </a:r>
-            <a:endParaRPr lang="en-US" sz="2800" dirty="0" b="1">
+            <a:endParaRPr lang="en-US" sz="2800" b="1" dirty="0">
               <a:latin typeface="Times New Roman"/>
               <a:ea typeface="Times New Roman"/>
               <a:cs typeface="Times New Roman"/>
@@ -14294,7 +15805,10 @@
         </p:spPr>
         <p:txBody>
           <a:bodyPr/>
-          <a:p/>
+          <a:lstStyle/>
+          <a:p>
+            <a:endParaRPr/>
+          </a:p>
         </p:txBody>
       </p:sp>
       <p:graphicFrame>
@@ -14313,7 +15827,7 @@
         </p:nvGraphicFramePr>
         <p:xfrm>
           <a:off x="1097280" y="1691640"/>
-          <a:ext cx="9966960" cy="3200400"/>
+          <a:ext cx="9966960" cy="3931920"/>
         </p:xfrm>
         <a:graphic>
           <a:graphicData uri="http://schemas.openxmlformats.org/drawingml/2006/table">
@@ -14362,7 +15876,7 @@
                         </a:rPr>
                         <a:t>Module</a:t>
                       </a:r>
-                      <a:endParaRPr lang="en-US" sz="2000" dirty="0" b="1">
+                      <a:endParaRPr lang="en-US" sz="2000" b="1" dirty="0">
                         <a:latin typeface="Times New Roman"/>
                         <a:ea typeface="Times New Roman"/>
                         <a:cs typeface="Times New Roman"/>
@@ -14430,7 +15944,7 @@
                         </a:rPr>
                         <a:t>Description</a:t>
                       </a:r>
-                      <a:endParaRPr lang="en-US" sz="2000" dirty="0" b="1">
+                      <a:endParaRPr lang="en-US" sz="2000" b="1" dirty="0">
                         <a:latin typeface="Times New Roman"/>
                         <a:ea typeface="Times New Roman"/>
                         <a:cs typeface="Times New Roman"/>
@@ -14498,7 +16012,7 @@
                         </a:rPr>
                         <a:t>Key Functions</a:t>
                       </a:r>
-                      <a:endParaRPr lang="en-US" sz="2000" dirty="0" b="1">
+                      <a:endParaRPr lang="en-US" sz="2000" b="1" dirty="0">
                         <a:latin typeface="Times New Roman"/>
                         <a:ea typeface="Times New Roman"/>
                         <a:cs typeface="Times New Roman"/>
@@ -15182,7 +16696,7 @@
                 </a:tc>
                 <a:extLst>
                   <a:ext uri="{0D108BD9-81ED-4DB2-BD59-A6C34878D82A}">
-                    <a16:rowId xmlns:a16="http://schemas.microsoft.com/office/drawing/2014/main" val="10001"/>
+                    <a16:rowId xmlns:a16="http://schemas.microsoft.com/office/drawing/2014/main" val="2653146778"/>
                   </a:ext>
                 </a:extLst>
               </a:tr>
@@ -15393,7 +16907,7 @@
                 </a:tc>
                 <a:extLst>
                   <a:ext uri="{0D108BD9-81ED-4DB2-BD59-A6C34878D82A}">
-                    <a16:rowId xmlns:a16="http://schemas.microsoft.com/office/drawing/2014/main" val="10002"/>
+                    <a16:rowId xmlns:a16="http://schemas.microsoft.com/office/drawing/2014/main" val="1988867004"/>
                   </a:ext>
                 </a:extLst>
               </a:tr>
@@ -15604,7 +17118,7 @@
                 </a:tc>
                 <a:extLst>
                   <a:ext uri="{0D108BD9-81ED-4DB2-BD59-A6C34878D82A}">
-                    <a16:rowId xmlns:a16="http://schemas.microsoft.com/office/drawing/2014/main" val="10001"/>
+                    <a16:rowId xmlns:a16="http://schemas.microsoft.com/office/drawing/2014/main" val="29939595"/>
                   </a:ext>
                 </a:extLst>
               </a:tr>
@@ -15815,7 +17329,7 @@
                 </a:tc>
                 <a:extLst>
                   <a:ext uri="{0D108BD9-81ED-4DB2-BD59-A6C34878D82A}">
-                    <a16:rowId xmlns:a16="http://schemas.microsoft.com/office/drawing/2014/main" val="10002"/>
+                    <a16:rowId xmlns:a16="http://schemas.microsoft.com/office/drawing/2014/main" val="4089794586"/>
                   </a:ext>
                 </a:extLst>
               </a:tr>
@@ -15917,7 +17431,7 @@
 </p:sld>
 </file>
 
-<file path=ppt/slides/slide7.xml><?xml version="1.0" encoding="utf-8"?>
+<file path=ppt/slides/slide8.xml><?xml version="1.0" encoding="utf-8"?>
 <p:sld xmlns:a="http://schemas.openxmlformats.org/drawingml/2006/main" xmlns:r="http://schemas.openxmlformats.org/officeDocument/2006/relationships" xmlns:p="http://schemas.openxmlformats.org/presentationml/2006/main">
   <p:cSld name="Slide 8">
     <p:bg>
@@ -15963,7 +17477,10 @@
         </p:spPr>
         <p:txBody>
           <a:bodyPr/>
-          <a:p/>
+          <a:lstStyle/>
+          <a:p>
+            <a:endParaRPr/>
+          </a:p>
         </p:txBody>
       </p:sp>
       <p:sp>
@@ -16001,7 +17518,7 @@
               </a:rPr>
               <a:t>06</a:t>
             </a:r>
-            <a:endParaRPr lang="en-US" sz="1800" dirty="0" b="1">
+            <a:endParaRPr lang="en-US" sz="1800" b="1" dirty="0">
               <a:latin typeface="Times New Roman"/>
               <a:ea typeface="Times New Roman"/>
               <a:cs typeface="Times New Roman"/>
@@ -16087,7 +17604,7 @@
               </a:rPr>
               <a:t>Technology Stack</a:t>
             </a:r>
-            <a:endParaRPr lang="en-US" sz="2800" dirty="0" b="1">
+            <a:endParaRPr lang="en-US" sz="2800" b="1" dirty="0">
               <a:latin typeface="Times New Roman"/>
               <a:ea typeface="Times New Roman"/>
               <a:cs typeface="Times New Roman"/>
@@ -16119,7 +17636,10 @@
         </p:spPr>
         <p:txBody>
           <a:bodyPr/>
-          <a:p/>
+          <a:lstStyle/>
+          <a:p>
+            <a:endParaRPr/>
+          </a:p>
         </p:txBody>
       </p:sp>
       <p:sp>
@@ -16150,7 +17670,10 @@
         </p:spPr>
         <p:txBody>
           <a:bodyPr/>
-          <a:p/>
+          <a:lstStyle/>
+          <a:p>
+            <a:endParaRPr/>
+          </a:p>
         </p:txBody>
       </p:sp>
       <p:sp>
@@ -16267,7 +17790,10 @@
         </p:spPr>
         <p:txBody>
           <a:bodyPr/>
-          <a:p/>
+          <a:lstStyle/>
+          <a:p>
+            <a:endParaRPr/>
+          </a:p>
         </p:txBody>
       </p:sp>
       <p:sp>
@@ -16384,7 +17910,10 @@
         </p:spPr>
         <p:txBody>
           <a:bodyPr/>
-          <a:p/>
+          <a:lstStyle/>
+          <a:p>
+            <a:endParaRPr/>
+          </a:p>
         </p:txBody>
       </p:sp>
       <p:sp>
@@ -16501,7 +18030,10 @@
         </p:spPr>
         <p:txBody>
           <a:bodyPr/>
-          <a:p/>
+          <a:lstStyle/>
+          <a:p>
+            <a:endParaRPr/>
+          </a:p>
         </p:txBody>
       </p:sp>
       <p:sp>
@@ -16874,7 +18406,7 @@
 </p:sld>
 </file>
 
-<file path=ppt/slides/slide8.xml><?xml version="1.0" encoding="utf-8"?>
+<file path=ppt/slides/slide9.xml><?xml version="1.0" encoding="utf-8"?>
 <p:sld xmlns:a="http://schemas.openxmlformats.org/drawingml/2006/main" xmlns:r="http://schemas.openxmlformats.org/officeDocument/2006/relationships" xmlns:p="http://schemas.openxmlformats.org/presentationml/2006/main">
   <p:cSld name="Slide 9">
     <p:bg>
@@ -16920,7 +18452,10 @@
         </p:spPr>
         <p:txBody>
           <a:bodyPr/>
-          <a:p/>
+          <a:lstStyle/>
+          <a:p>
+            <a:endParaRPr/>
+          </a:p>
         </p:txBody>
       </p:sp>
       <p:sp>
@@ -16958,7 +18493,7 @@
               </a:rPr>
               <a:t>07</a:t>
             </a:r>
-            <a:endParaRPr lang="en-US" sz="1800" dirty="0" b="1">
+            <a:endParaRPr lang="en-US" sz="1800" b="1" dirty="0">
               <a:latin typeface="Times New Roman"/>
               <a:ea typeface="Times New Roman"/>
               <a:cs typeface="Times New Roman"/>
@@ -17044,7 +18579,7 @@
               </a:rPr>
               <a:t>UI Design / Wireframes</a:t>
             </a:r>
-            <a:endParaRPr lang="en-US" sz="2800" dirty="0" b="1">
+            <a:endParaRPr lang="en-US" sz="2800" b="1" dirty="0">
               <a:latin typeface="Times New Roman"/>
               <a:ea typeface="Times New Roman"/>
               <a:cs typeface="Times New Roman"/>
@@ -17076,7 +18611,10 @@
         </p:spPr>
         <p:txBody>
           <a:bodyPr/>
-          <a:p/>
+          <a:lstStyle/>
+          <a:p>
+            <a:endParaRPr/>
+          </a:p>
         </p:txBody>
       </p:sp>
       <p:sp>
@@ -17107,7 +18645,10 @@
         </p:spPr>
         <p:txBody>
           <a:bodyPr/>
-          <a:p/>
+          <a:lstStyle/>
+          <a:p>
+            <a:endParaRPr/>
+          </a:p>
         </p:txBody>
       </p:sp>
       <p:sp>
@@ -17138,7 +18679,10 @@
         </p:spPr>
         <p:txBody>
           <a:bodyPr/>
-          <a:p/>
+          <a:lstStyle/>
+          <a:p>
+            <a:endParaRPr/>
+          </a:p>
         </p:txBody>
       </p:sp>
       <p:sp>
@@ -17176,7 +18720,7 @@
               </a:rPr>
               <a:t>Design Highlights</a:t>
             </a:r>
-            <a:endParaRPr lang="en-US" sz="2000" dirty="0" b="1">
+            <a:endParaRPr lang="en-US" sz="2000" b="1" dirty="0">
               <a:latin typeface="Times New Roman"/>
               <a:ea typeface="Times New Roman"/>
               <a:cs typeface="Times New Roman"/>
@@ -17441,576 +18985,6 @@
           </a:prstGeom>
         </p:spPr>
       </p:pic>
-    </p:spTree>
-  </p:cSld>
-  <p:clrMapOvr>
-    <a:masterClrMapping/>
-  </p:clrMapOvr>
-</p:sld>
-</file>
-
-<file path=ppt/slides/slide9.xml><?xml version="1.0" encoding="utf-8"?>
-<p:sld xmlns:a="http://schemas.openxmlformats.org/drawingml/2006/main" xmlns:r="http://schemas.openxmlformats.org/officeDocument/2006/relationships" xmlns:p="http://schemas.openxmlformats.org/presentationml/2006/main">
-  <p:cSld name="Slide 10">
-    <p:bg>
-      <p:bgPr>
-        <a:solidFill>
-          <a:srgbClr val="FFFFFF"/>
-        </a:solidFill>
-        <a:effectLst/>
-      </p:bgPr>
-    </p:bg>
-    <p:spTree>
-      <p:nvGrpSpPr>
-        <p:cNvPr id="1" name=""/>
-        <p:cNvGrpSpPr/>
-        <p:nvPr/>
-      </p:nvGrpSpPr>
-      <p:grpSpPr>
-        <a:xfrm>
-          <a:off x="0" y="0"/>
-          <a:ext cx="0" cy="0"/>
-          <a:chOff x="0" y="0"/>
-          <a:chExt cx="0" cy="0"/>
-        </a:xfrm>
-      </p:grpSpPr>
-      <p:sp>
-        <p:nvSpPr>
-          <p:cNvPr id="2" name="Shape 0"/>
-          <p:cNvSpPr/>
-          <p:nvPr/>
-        </p:nvSpPr>
-        <p:spPr>
-          <a:xfrm>
-            <a:off x="457200" y="457200"/>
-            <a:ext cx="502920" cy="502920"/>
-          </a:xfrm>
-          <a:prstGeom prst="ellipse">
-            <a:avLst/>
-          </a:prstGeom>
-          <a:solidFill>
-            <a:srgbClr val="00A896"/>
-          </a:solidFill>
-          <a:ln/>
-        </p:spPr>
-        <p:txBody>
-          <a:bodyPr/>
-          <a:p/>
-        </p:txBody>
-      </p:sp>
-      <p:sp>
-        <p:nvSpPr>
-          <p:cNvPr id="3" name="Text 1"/>
-          <p:cNvSpPr txBox="1"/>
-          <p:nvPr/>
-        </p:nvSpPr>
-        <p:spPr>
-          <a:xfrm>
-            <a:off x="457200" y="457200"/>
-            <a:ext cx="502920" cy="502920"/>
-          </a:xfrm>
-          <a:prstGeom prst="rect">
-            <a:avLst/>
-          </a:prstGeom>
-          <a:noFill/>
-          <a:ln/>
-        </p:spPr>
-        <p:txBody>
-          <a:bodyPr wrap="square" lIns="0" tIns="0" rIns="0" bIns="0" rtlCol="0" anchor="ctr"/>
-          <a:lstStyle/>
-          <a:p>
-            <a:pPr marL="0" indent="0" algn="ctr">
-              <a:buNone/>
-            </a:pPr>
-            <a:r>
-              <a:rPr lang="en-US" sz="1800" b="1" dirty="0">
-                <a:solidFill>
-                  <a:srgbClr val="FFFFFF"/>
-                </a:solidFill>
-                <a:latin typeface="Times New Roman"/>
-                <a:ea typeface="Times New Roman"/>
-                <a:cs typeface="Times New Roman"/>
-              </a:rPr>
-              <a:t>08</a:t>
-            </a:r>
-            <a:endParaRPr lang="en-US" sz="1800" dirty="0" b="1">
-              <a:latin typeface="Times New Roman"/>
-              <a:ea typeface="Times New Roman"/>
-              <a:cs typeface="Times New Roman"/>
-            </a:endParaRPr>
-          </a:p>
-        </p:txBody>
-      </p:sp>
-      <p:sp>
-        <p:nvSpPr>
-          <p:cNvPr id="4" name="Text 2"/>
-          <p:cNvSpPr txBox="1"/>
-          <p:nvPr/>
-        </p:nvSpPr>
-        <p:spPr>
-          <a:xfrm>
-            <a:off x="1097280" y="457200"/>
-            <a:ext cx="5486400" cy="274320"/>
-          </a:xfrm>
-          <a:prstGeom prst="rect">
-            <a:avLst/>
-          </a:prstGeom>
-          <a:noFill/>
-          <a:ln/>
-        </p:spPr>
-        <p:txBody>
-          <a:bodyPr wrap="square" lIns="0" tIns="0" rIns="0" bIns="0" rtlCol="0" anchor="ctr"/>
-          <a:lstStyle/>
-          <a:p>
-            <a:pPr marL="0" indent="0">
-              <a:buNone/>
-            </a:pPr>
-            <a:r>
-              <a:rPr lang="en-US" sz="2000" b="1" kern="0" spc="200" dirty="0">
-                <a:solidFill>
-                  <a:srgbClr val="00A896"/>
-                </a:solidFill>
-                <a:latin typeface="Times New Roman"/>
-                <a:ea typeface="Times New Roman"/>
-                <a:cs typeface="Times New Roman"/>
-              </a:rPr>
-              <a:t>FRONTEND</a:t>
-            </a:r>
-            <a:endParaRPr lang="en-US" sz="2000" dirty="0">
-              <a:latin typeface="Times New Roman"/>
-              <a:ea typeface="Times New Roman"/>
-              <a:cs typeface="Times New Roman"/>
-            </a:endParaRPr>
-          </a:p>
-        </p:txBody>
-      </p:sp>
-      <p:sp>
-        <p:nvSpPr>
-          <p:cNvPr id="5" name="Text 3"/>
-          <p:cNvSpPr txBox="1"/>
-          <p:nvPr/>
-        </p:nvSpPr>
-        <p:spPr>
-          <a:xfrm>
-            <a:off x="1097280" y="713232"/>
-            <a:ext cx="10515600" cy="548640"/>
-          </a:xfrm>
-          <a:prstGeom prst="rect">
-            <a:avLst/>
-          </a:prstGeom>
-          <a:noFill/>
-          <a:ln/>
-        </p:spPr>
-        <p:txBody>
-          <a:bodyPr wrap="square" lIns="0" tIns="0" rIns="0" bIns="0" rtlCol="0" anchor="ctr"/>
-          <a:lstStyle/>
-          <a:p>
-            <a:pPr marL="0" indent="0">
-              <a:buNone/>
-            </a:pPr>
-            <a:r>
-              <a:rPr lang="en-US" sz="2800" b="1" dirty="0">
-                <a:solidFill>
-                  <a:srgbClr val="1B2A2E"/>
-                </a:solidFill>
-                <a:latin typeface="Times New Roman"/>
-                <a:ea typeface="Times New Roman"/>
-                <a:cs typeface="Times New Roman"/>
-              </a:rPr>
-              <a:t>Frontend Development</a:t>
-            </a:r>
-            <a:endParaRPr lang="en-US" sz="2800" dirty="0" b="1">
-              <a:latin typeface="Times New Roman"/>
-              <a:ea typeface="Times New Roman"/>
-              <a:cs typeface="Times New Roman"/>
-            </a:endParaRPr>
-          </a:p>
-        </p:txBody>
-      </p:sp>
-      <p:sp>
-        <p:nvSpPr>
-          <p:cNvPr id="6" name="Shape 4"/>
-          <p:cNvSpPr/>
-          <p:nvPr/>
-        </p:nvSpPr>
-        <p:spPr>
-          <a:xfrm>
-            <a:off x="1097280" y="1371600"/>
-            <a:ext cx="10607040" cy="0"/>
-          </a:xfrm>
-          <a:prstGeom prst="line">
-            <a:avLst/>
-          </a:prstGeom>
-          <a:noFill/>
-          <a:ln w="12700">
-            <a:solidFill>
-              <a:srgbClr val="D7E7E5"/>
-            </a:solidFill>
-            <a:prstDash val="solid"/>
-          </a:ln>
-        </p:spPr>
-        <p:txBody>
-          <a:bodyPr/>
-          <a:p/>
-        </p:txBody>
-      </p:sp>
-      <p:sp>
-        <p:nvSpPr>
-          <p:cNvPr id="7" name="Text 5"/>
-          <p:cNvSpPr txBox="1"/>
-          <p:nvPr/>
-        </p:nvSpPr>
-        <p:spPr>
-          <a:xfrm>
-            <a:off x="1097280" y="1691640"/>
-            <a:ext cx="9875520" cy="4206240"/>
-          </a:xfrm>
-          <a:prstGeom prst="rect">
-            <a:avLst/>
-          </a:prstGeom>
-          <a:noFill/>
-          <a:ln/>
-        </p:spPr>
-        <p:txBody>
-          <a:bodyPr wrap="square" lIns="0" tIns="0" rIns="0" bIns="0" rtlCol="0" anchor="ctr"/>
-          <a:lstStyle/>
-          <a:p>
-            <a:pPr marL="342900" indent="-342900">
-              <a:spcAft>
-                <a:spcPts val="400"/>
-              </a:spcAft>
-              <a:buSzPct val="100000"/>
-              <a:buChar char="▪"/>
-            </a:pPr>
-            <a:r>
-              <a:rPr lang="en-US" sz="1800" dirty="0">
-                <a:solidFill>
-                  <a:srgbClr val="1B2A2E"/>
-                </a:solidFill>
-                <a:latin typeface="Times New Roman"/>
-                <a:ea typeface="Times New Roman"/>
-                <a:cs typeface="Times New Roman"/>
-              </a:rPr>
-              <a:t>React 18 + Vite 5 with functional components and hooks (64 JSX files)</a:t>
-            </a:r>
-            <a:endParaRPr lang="en-US" sz="1800" dirty="0">
-              <a:latin typeface="Times New Roman"/>
-              <a:ea typeface="Times New Roman"/>
-              <a:cs typeface="Times New Roman"/>
-            </a:endParaRPr>
-          </a:p>
-          <a:p>
-            <a:pPr marL="342900" indent="-342900">
-              <a:spcAft>
-                <a:spcPts val="400"/>
-              </a:spcAft>
-              <a:buSzPct val="100000"/>
-              <a:buChar char="▪"/>
-            </a:pPr>
-            <a:r>
-              <a:rPr lang="en-US" sz="1800" dirty="0">
-                <a:solidFill>
-                  <a:srgbClr val="1B2A2E"/>
-                </a:solidFill>
-                <a:latin typeface="Times New Roman"/>
-                <a:ea typeface="Times New Roman"/>
-                <a:cs typeface="Times New Roman"/>
-              </a:rPr>
-              <a:t>React Router: 25 routes across public, auth, user and admin areas</a:t>
-            </a:r>
-            <a:endParaRPr lang="en-US" sz="1800" dirty="0">
-              <a:latin typeface="Times New Roman"/>
-              <a:ea typeface="Times New Roman"/>
-              <a:cs typeface="Times New Roman"/>
-            </a:endParaRPr>
-          </a:p>
-          <a:p>
-            <a:pPr marL="342900" indent="-342900">
-              <a:spcAft>
-                <a:spcPts val="400"/>
-              </a:spcAft>
-              <a:buSzPct val="100000"/>
-              <a:buChar char="▪"/>
-            </a:pPr>
-            <a:r>
-              <a:rPr lang="en-US" sz="1800" dirty="0">
-                <a:solidFill>
-                  <a:srgbClr val="1B2A2E"/>
-                </a:solidFill>
-                <a:latin typeface="Times New Roman"/>
-                <a:ea typeface="Times New Roman"/>
-                <a:cs typeface="Times New Roman"/>
-              </a:rPr>
-              <a:t>Context API for auth and theme; Axios client with JWT interceptor</a:t>
-            </a:r>
-            <a:endParaRPr lang="en-US" sz="1800" dirty="0">
-              <a:latin typeface="Times New Roman"/>
-              <a:ea typeface="Times New Roman"/>
-              <a:cs typeface="Times New Roman"/>
-            </a:endParaRPr>
-          </a:p>
-          <a:p>
-            <a:pPr marL="342900" indent="-342900">
-              <a:spcAft>
-                <a:spcPts val="400"/>
-              </a:spcAft>
-              <a:buSzPct val="100000"/>
-              <a:buChar char="▪"/>
-            </a:pPr>
-            <a:r>
-              <a:rPr lang="en-US" sz="1800" dirty="0">
-                <a:solidFill>
-                  <a:srgbClr val="1B2A2E"/>
-                </a:solidFill>
-                <a:latin typeface="Times New Roman"/>
-                <a:ea typeface="Times New Roman"/>
-                <a:cs typeface="Times New Roman"/>
-              </a:rPr>
-              <a:t>Analyze page: link or paste mode, live progress over Socket.IO</a:t>
-            </a:r>
-            <a:endParaRPr lang="en-US" sz="1800" dirty="0">
-              <a:latin typeface="Times New Roman"/>
-              <a:ea typeface="Times New Roman"/>
-              <a:cs typeface="Times New Roman"/>
-            </a:endParaRPr>
-          </a:p>
-          <a:p>
-            <a:pPr marL="342900" indent="-342900">
-              <a:spcAft>
-                <a:spcPts val="400"/>
-              </a:spcAft>
-              <a:buSzPct val="100000"/>
-              <a:buChar char="▪"/>
-            </a:pPr>
-            <a:r>
-              <a:rPr lang="en-US" sz="1800" dirty="0">
-                <a:solidFill>
-                  <a:srgbClr val="1B2A2E"/>
-                </a:solidFill>
-                <a:latin typeface="Times New Roman"/>
-                <a:ea typeface="Times New Roman"/>
-                <a:cs typeface="Times New Roman"/>
-              </a:rPr>
-              <a:t>Report page: score ring, factor bars, caps, confidence, claims, PDF</a:t>
-            </a:r>
-            <a:endParaRPr lang="en-US" sz="1800" dirty="0">
-              <a:latin typeface="Times New Roman"/>
-              <a:ea typeface="Times New Roman"/>
-              <a:cs typeface="Times New Roman"/>
-            </a:endParaRPr>
-          </a:p>
-          <a:p>
-            <a:pPr marL="342900" indent="-342900">
-              <a:spcAft>
-                <a:spcPts val="400"/>
-              </a:spcAft>
-              <a:buSzPct val="100000"/>
-              <a:buChar char="▪"/>
-            </a:pPr>
-            <a:r>
-              <a:rPr lang="en-US" sz="1800" dirty="0">
-                <a:solidFill>
-                  <a:srgbClr val="1B2A2E"/>
-                </a:solidFill>
-                <a:latin typeface="Times New Roman"/>
-                <a:ea typeface="Times New Roman"/>
-                <a:cs typeface="Times New Roman"/>
-              </a:rPr>
-              <a:t>Bootstrap 5 with custom design tokens, light and dark mode</a:t>
-            </a:r>
-            <a:endParaRPr lang="en-US" sz="1800" dirty="0">
-              <a:latin typeface="Times New Roman"/>
-              <a:ea typeface="Times New Roman"/>
-              <a:cs typeface="Times New Roman"/>
-            </a:endParaRPr>
-          </a:p>
-          <a:p>
-            <a:pPr marL="342900" indent="-342900">
-              <a:spcAft>
-                <a:spcPts val="400"/>
-              </a:spcAft>
-              <a:buSzPct val="100000"/>
-              <a:buChar char="▪"/>
-            </a:pPr>
-            <a:r>
-              <a:rPr lang="en-US" sz="1800" dirty="0">
-                <a:solidFill>
-                  <a:srgbClr val="1B2A2E"/>
-                </a:solidFill>
-                <a:latin typeface="Times New Roman"/>
-                <a:ea typeface="Times New Roman"/>
-                <a:cs typeface="Times New Roman"/>
-              </a:rPr>
-              <a:t>Chart.js dashboards; admin and report pages lazy-loaded</a:t>
-            </a:r>
-            <a:endParaRPr lang="en-US" sz="1800" dirty="0">
-              <a:latin typeface="Times New Roman"/>
-              <a:ea typeface="Times New Roman"/>
-              <a:cs typeface="Times New Roman"/>
-            </a:endParaRPr>
-          </a:p>
-        </p:txBody>
-      </p:sp>
-      <p:sp>
-        <p:nvSpPr>
-          <p:cNvPr id="8" name="Shape 6"/>
-          <p:cNvSpPr/>
-          <p:nvPr/>
-        </p:nvSpPr>
-        <p:spPr>
-          <a:xfrm>
-            <a:off x="1097280" y="5623560"/>
-            <a:ext cx="9966960" cy="594360"/>
-          </a:xfrm>
-          <a:prstGeom prst="roundRect">
-            <a:avLst>
-              <a:gd name="adj" fmla="val 12308"/>
-            </a:avLst>
-          </a:prstGeom>
-          <a:solidFill>
-            <a:srgbClr val="F4FAF9"/>
-          </a:solidFill>
-          <a:ln w="12700">
-            <a:solidFill>
-              <a:srgbClr val="D7E7E5"/>
-            </a:solidFill>
-            <a:prstDash val="solid"/>
-          </a:ln>
-        </p:spPr>
-        <p:txBody>
-          <a:bodyPr/>
-          <a:p/>
-        </p:txBody>
-      </p:sp>
-      <p:sp>
-        <p:nvSpPr>
-          <p:cNvPr id="9" name="Text 7"/>
-          <p:cNvSpPr txBox="1"/>
-          <p:nvPr/>
-        </p:nvSpPr>
-        <p:spPr>
-          <a:xfrm>
-            <a:off x="1325880" y="5623560"/>
-            <a:ext cx="9509760" cy="594360"/>
-          </a:xfrm>
-          <a:prstGeom prst="rect">
-            <a:avLst/>
-          </a:prstGeom>
-          <a:noFill/>
-          <a:ln/>
-        </p:spPr>
-        <p:txBody>
-          <a:bodyPr wrap="square" lIns="0" tIns="0" rIns="0" bIns="0" rtlCol="0" anchor="ctr"/>
-          <a:lstStyle/>
-          <a:p>
-            <a:pPr marL="0" indent="0">
-              <a:buNone/>
-            </a:pPr>
-            <a:r>
-              <a:rPr lang="en-US" sz="1800" i="1" dirty="0">
-                <a:solidFill>
-                  <a:srgbClr val="3E5C58"/>
-                </a:solidFill>
-                <a:latin typeface="Times New Roman"/>
-                <a:ea typeface="Times New Roman"/>
-                <a:cs typeface="Times New Roman"/>
-              </a:rPr>
-              <a:t>Done: Landing, Login, Register, OTP, Reset, Dashboard, Analyze, Report, History, Saved, Sources, Notifications, Settings, 8 admin pages.</a:t>
-            </a:r>
-            <a:endParaRPr lang="en-US" sz="1800" dirty="0">
-              <a:latin typeface="Times New Roman"/>
-              <a:ea typeface="Times New Roman"/>
-              <a:cs typeface="Times New Roman"/>
-            </a:endParaRPr>
-          </a:p>
-        </p:txBody>
-      </p:sp>
-      <p:sp>
-        <p:nvSpPr>
-          <p:cNvPr id="10" name="Text 8"/>
-          <p:cNvSpPr txBox="1"/>
-          <p:nvPr/>
-        </p:nvSpPr>
-        <p:spPr>
-          <a:xfrm>
-            <a:off x="457200" y="6473952"/>
-            <a:ext cx="5486400" cy="274320"/>
-          </a:xfrm>
-          <a:prstGeom prst="rect">
-            <a:avLst/>
-          </a:prstGeom>
-          <a:noFill/>
-          <a:ln/>
-        </p:spPr>
-        <p:txBody>
-          <a:bodyPr wrap="square" lIns="0" tIns="0" rIns="0" bIns="0" rtlCol="0" anchor="ctr"/>
-          <a:lstStyle/>
-          <a:p>
-            <a:pPr marL="0" indent="0">
-              <a:buNone/>
-            </a:pPr>
-            <a:r>
-              <a:rPr lang="en-US" sz="1800" dirty="0">
-                <a:solidFill>
-                  <a:srgbClr val="7A8F8C"/>
-                </a:solidFill>
-                <a:latin typeface="Times New Roman"/>
-                <a:ea typeface="Times New Roman"/>
-                <a:cs typeface="Times New Roman"/>
-              </a:rPr>
-              <a:t>Frontend</a:t>
-            </a:r>
-            <a:endParaRPr lang="en-US" sz="1800" dirty="0">
-              <a:latin typeface="Times New Roman"/>
-              <a:ea typeface="Times New Roman"/>
-              <a:cs typeface="Times New Roman"/>
-            </a:endParaRPr>
-          </a:p>
-        </p:txBody>
-      </p:sp>
-      <p:sp>
-        <p:nvSpPr>
-          <p:cNvPr id="11" name="Text 9"/>
-          <p:cNvSpPr txBox="1"/>
-          <p:nvPr/>
-        </p:nvSpPr>
-        <p:spPr>
-          <a:xfrm>
-            <a:off x="6245352" y="6473952"/>
-            <a:ext cx="5486400" cy="274320"/>
-          </a:xfrm>
-          <a:prstGeom prst="rect">
-            <a:avLst/>
-          </a:prstGeom>
-          <a:noFill/>
-          <a:ln/>
-        </p:spPr>
-        <p:txBody>
-          <a:bodyPr wrap="square" lIns="0" tIns="0" rIns="0" bIns="0" rtlCol="0" anchor="ctr"/>
-          <a:lstStyle/>
-          <a:p>
-            <a:pPr marL="0" indent="0" algn="r">
-              <a:buNone/>
-            </a:pPr>
-            <a:r>
-              <a:rPr lang="en-US" sz="1800" dirty="0">
-                <a:solidFill>
-                  <a:srgbClr val="7A8F8C"/>
-                </a:solidFill>
-                <a:latin typeface="Times New Roman"/>
-                <a:ea typeface="Times New Roman"/>
-                <a:cs typeface="Times New Roman"/>
-              </a:rPr>
-              <a:t>Review 1  |  NewsGuard AI (MERN Stack)</a:t>
-            </a:r>
-            <a:endParaRPr lang="en-US" sz="1800" dirty="0">
-              <a:latin typeface="Times New Roman"/>
-              <a:ea typeface="Times New Roman"/>
-              <a:cs typeface="Times New Roman"/>
-            </a:endParaRPr>
-          </a:p>
-        </p:txBody>
-      </p:sp>
     </p:spTree>
   </p:cSld>
   <p:clrMapOvr>

</xml_diff>